<commit_message>
Real data validation on CGMacros, documentation and slides for version 1.1
* prativimb/eval/real_data.py and scripts/fetch_cgmacros.sh: 45 real
  participants, checksum verified download, data not redistributed.
  Twin with announced meals cuts 2 h RMSE from 38.3 to 29.6 mg/dL;
  synthetic trained models land near persistence; conformal coverage
  recovers from 78% to 88% with per site recalibration.
* EHR prior tolerates missing values; calibration window is a parameter.
* Fix: reported new time of a moved meal in what-if (regression test).
* README, MODEL_CARD, DATA (with CGMacros citation and licence), video
  script, 15 slide deck, model card page and screenshots updated.
</commit_message>
<xml_diff>
--- a/docs/presentation.pptx
+++ b/docs/presentation.pptx
@@ -3292,7 +3292,7 @@
             <a:r>
               <a:rPr sz="1400" b="0" i="0">
                 <a:solidFill>
-                  <a:srgbClr val="75726B"/>
+                  <a:srgbClr val="6A675F"/>
                 </a:solidFill>
                 <a:latin typeface="IBM Plex Sans"/>
               </a:rPr>
@@ -3309,7 +3309,7 @@
         </p:nvSpPr>
         <p:spPr>
           <a:xfrm>
-            <a:off x="822960" y="5760720"/>
+            <a:off x="822960" y="4983480"/>
             <a:ext cx="10058400" cy="365760"/>
           </a:xfrm>
           <a:prstGeom prst="rect">
@@ -3329,13 +3329,91 @@
               </a:lnSpc>
             </a:pPr>
             <a:r>
-              <a:rPr sz="1200" b="0" i="0">
-                <a:solidFill>
-                  <a:srgbClr val="75726B"/>
-                </a:solidFill>
-                <a:latin typeface="IBM Plex Sans"/>
-              </a:rPr>
-              <a:t>&lt;TeamName&gt;, &lt;CollegeName&gt;.  Prativimb is Sanskrit for reflection. All patient data shown is synthetic.</a:t>
+              <a:rPr sz="1500" b="0" i="0">
+                <a:solidFill>
+                  <a:srgbClr val="1B1B19"/>
+                </a:solidFill>
+                <a:latin typeface="IBM Plex Sans"/>
+              </a:rPr>
+              <a:t>&lt;TeamName&gt;, &lt;CollegeName&gt; / &lt;Incubator&gt;</a:t>
+            </a:r>
+          </a:p>
+        </p:txBody>
+      </p:sp>
+      <p:sp>
+        <p:nvSpPr>
+          <p:cNvPr id="8" name="TextBox 7"/>
+          <p:cNvSpPr txBox="1"/>
+          <p:nvPr/>
+        </p:nvSpPr>
+        <p:spPr>
+          <a:xfrm>
+            <a:off x="822960" y="5394960"/>
+            <a:ext cx="10515600" cy="365760"/>
+          </a:xfrm>
+          <a:prstGeom prst="rect">
+            <a:avLst/>
+          </a:prstGeom>
+          <a:noFill/>
+        </p:spPr>
+        <p:txBody>
+          <a:bodyPr wrap="none" lIns="0" rIns="0" tIns="0" bIns="0">
+            <a:spAutoFit/>
+          </a:bodyPr>
+          <a:lstStyle/>
+          <a:p>
+            <a:pPr>
+              <a:lnSpc>
+                <a:spcPct val="135000"/>
+              </a:lnSpc>
+            </a:pPr>
+            <a:r>
+              <a:rPr sz="1250" b="0" i="0">
+                <a:solidFill>
+                  <a:srgbClr val="4A4843"/>
+                </a:solidFill>
+                <a:latin typeface="IBM Plex Sans"/>
+              </a:rPr>
+              <a:t>&lt;Member 1, role&gt;   &lt;Member 2, role&gt;   &lt;Member 3, role&gt;   &lt;Member 4, role&gt;   &lt;team email&gt;</a:t>
+            </a:r>
+          </a:p>
+        </p:txBody>
+      </p:sp>
+      <p:sp>
+        <p:nvSpPr>
+          <p:cNvPr id="9" name="TextBox 8"/>
+          <p:cNvSpPr txBox="1"/>
+          <p:nvPr/>
+        </p:nvSpPr>
+        <p:spPr>
+          <a:xfrm>
+            <a:off x="822960" y="5989320"/>
+            <a:ext cx="10515600" cy="365760"/>
+          </a:xfrm>
+          <a:prstGeom prst="rect">
+            <a:avLst/>
+          </a:prstGeom>
+          <a:noFill/>
+        </p:spPr>
+        <p:txBody>
+          <a:bodyPr wrap="none" lIns="0" rIns="0" tIns="0" bIns="0">
+            <a:spAutoFit/>
+          </a:bodyPr>
+          <a:lstStyle/>
+          <a:p>
+            <a:pPr>
+              <a:lnSpc>
+                <a:spcPct val="135000"/>
+              </a:lnSpc>
+            </a:pPr>
+            <a:r>
+              <a:rPr sz="1100" b="0" i="0">
+                <a:solidFill>
+                  <a:srgbClr val="6A675F"/>
+                </a:solidFill>
+                <a:latin typeface="IBM Plex Sans"/>
+              </a:rPr>
+              <a:t>Prativimb is Sanskrit for reflection. Patient data shown is synthetic; real data validation uses open access CGMacros.</a:t>
             </a:r>
           </a:p>
         </p:txBody>
@@ -3396,7 +3474,7 @@
             <a:r>
               <a:rPr sz="1000" b="0" i="0">
                 <a:solidFill>
-                  <a:srgbClr val="75726B"/>
+                  <a:srgbClr val="6A675F"/>
                 </a:solidFill>
                 <a:latin typeface="IBM Plex Sans"/>
               </a:rPr>
@@ -3509,7 +3587,7 @@
             <a:r>
               <a:rPr sz="900" b="0" i="0">
                 <a:solidFill>
-                  <a:srgbClr val="75726B"/>
+                  <a:srgbClr val="6A675F"/>
                 </a:solidFill>
                 <a:latin typeface="IBM Plex Sans"/>
               </a:rPr>
@@ -3653,11 +3731,11 @@
             <a:r>
               <a:rPr sz="1000" b="0" i="0">
                 <a:solidFill>
-                  <a:srgbClr val="75726B"/>
-                </a:solidFill>
-                <a:latin typeface="IBM Plex Sans"/>
-              </a:rPr>
-              <a:t>CASE STUDY</a:t>
+                  <a:srgbClr val="6A675F"/>
+                </a:solidFill>
+                <a:latin typeface="IBM Plex Sans"/>
+              </a:rPr>
+              <a:t>VALIDATION</a:t>
             </a:r>
           </a:p>
         </p:txBody>
@@ -3696,7 +3774,7 @@
                 </a:solidFill>
                 <a:latin typeface="IBM Plex Serif"/>
               </a:rPr>
-              <a:t>What if: Ramesh, 52, night shift, T2D</a:t>
+              <a:t>Real CGM traces: what transfers and what does not</a:t>
             </a:r>
           </a:p>
         </p:txBody>
@@ -3766,7 +3844,7 @@
             <a:r>
               <a:rPr sz="900" b="0" i="0">
                 <a:solidFill>
-                  <a:srgbClr val="75726B"/>
+                  <a:srgbClr val="6A675F"/>
                 </a:solidFill>
                 <a:latin typeface="IBM Plex Sans"/>
               </a:rPr>
@@ -3777,7 +3855,7 @@
       </p:sp>
       <p:pic>
         <p:nvPicPr>
-          <p:cNvPr id="6" name="Picture 5" descr="03_whatif_ramesh.png"/>
+          <p:cNvPr id="6" name="Picture 5" descr="real_data_cgmacros.png"/>
           <p:cNvPicPr>
             <a:picLocks noChangeAspect="1"/>
           </p:cNvPicPr>
@@ -3791,17 +3869,12 @@
         </p:blipFill>
         <p:spPr>
           <a:xfrm>
-            <a:off x="548640" y="1325880"/>
-            <a:ext cx="6943725" cy="4443984"/>
-          </a:xfrm>
-          <a:prstGeom prst="rect">
-            <a:avLst/>
-          </a:prstGeom>
-          <a:ln w="9525">
-            <a:solidFill>
-              <a:srgbClr val="D8D3C8"/>
-            </a:solidFill>
-          </a:ln>
+            <a:off x="548640" y="1371600"/>
+            <a:ext cx="10599570" cy="3931920"/>
+          </a:xfrm>
+          <a:prstGeom prst="rect">
+            <a:avLst/>
+          </a:prstGeom>
         </p:spPr>
       </p:pic>
       <p:sp>
@@ -3812,241 +3885,65 @@
         </p:nvSpPr>
         <p:spPr>
           <a:xfrm>
-            <a:off x="7863840" y="1463040"/>
-            <a:ext cx="3840480" cy="3211830"/>
-          </a:xfrm>
-          <a:prstGeom prst="rect">
-            <a:avLst/>
-          </a:prstGeom>
-          <a:noFill/>
-        </p:spPr>
-        <p:txBody>
-          <a:bodyPr wrap="none" lIns="0" rIns="0" tIns="0" bIns="0">
-            <a:spAutoFit/>
-          </a:bodyPr>
-          <a:lstStyle/>
-          <a:p>
-            <a:pPr>
-              <a:lnSpc>
-                <a:spcPct val="135000"/>
-              </a:lnSpc>
-            </a:pPr>
-            <a:r>
-              <a:rPr sz="1300" b="0" i="0">
-                <a:solidFill>
-                  <a:srgbClr val="1B1B19"/>
-                </a:solidFill>
-                <a:latin typeface="IBM Plex Sans"/>
-              </a:rPr>
-              <a:t>•  19:45. The hybrid forecast expects dinner at</a:t>
-            </a:r>
-          </a:p>
-          <a:p>
-            <a:pPr>
-              <a:lnSpc>
-                <a:spcPct val="135000"/>
-              </a:lnSpc>
-            </a:pPr>
-            <a:r>
-              <a:rPr sz="1300" b="0" i="0">
-                <a:solidFill>
-                  <a:srgbClr val="1B1B19"/>
-                </a:solidFill>
-                <a:latin typeface="IBM Plex Sans"/>
-              </a:rPr>
-              <a:t>   20:15 and a peak near 278 mg/dL, after three</a:t>
-            </a:r>
-          </a:p>
-          <a:p>
-            <a:pPr>
-              <a:lnSpc>
-                <a:spcPct val="135000"/>
-              </a:lnSpc>
-            </a:pPr>
-            <a:r>
-              <a:rPr sz="1300" b="0" i="0">
-                <a:solidFill>
-                  <a:srgbClr val="1B1B19"/>
-                </a:solidFill>
-                <a:latin typeface="IBM Plex Sans"/>
-              </a:rPr>
-              <a:t>   nights of 4.9 h sleep.</a:t>
-            </a:r>
-          </a:p>
-          <a:p>
-            <a:pPr>
-              <a:lnSpc>
-                <a:spcPct val="135000"/>
-              </a:lnSpc>
-            </a:pPr>
-            <a:r>
-              <a:rPr sz="1300" b="0" i="0">
-                <a:solidFill>
-                  <a:srgbClr val="1B1B19"/>
-                </a:solidFill>
-                <a:latin typeface="IBM Plex Sans"/>
-              </a:rPr>
-              <a:t/>
-            </a:r>
-          </a:p>
-          <a:p>
-            <a:pPr>
-              <a:lnSpc>
-                <a:spcPct val="135000"/>
-              </a:lnSpc>
-            </a:pPr>
-            <a:r>
-              <a:rPr sz="1300" b="0" i="0">
-                <a:solidFill>
-                  <a:srgbClr val="1B1B19"/>
-                </a:solidFill>
-                <a:latin typeface="IBM Plex Sans"/>
-              </a:rPr>
-              <a:t>•  A 15 minute walk after dinner takes 15 mg/dL</a:t>
-            </a:r>
-          </a:p>
-          <a:p>
-            <a:pPr>
-              <a:lnSpc>
-                <a:spcPct val="135000"/>
-              </a:lnSpc>
-            </a:pPr>
-            <a:r>
-              <a:rPr sz="1300" b="0" i="0">
-                <a:solidFill>
-                  <a:srgbClr val="1B1B19"/>
-                </a:solidFill>
-                <a:latin typeface="IBM Plex Sans"/>
-              </a:rPr>
-              <a:t>   off the twin's 6 hour peak. Millets instead of</a:t>
-            </a:r>
-          </a:p>
-          <a:p>
-            <a:pPr>
-              <a:lnSpc>
-                <a:spcPct val="135000"/>
-              </a:lnSpc>
-            </a:pPr>
-            <a:r>
-              <a:rPr sz="1300" b="0" i="0">
-                <a:solidFill>
-                  <a:srgbClr val="1B1B19"/>
-                </a:solidFill>
-                <a:latin typeface="IBM Plex Sans"/>
-              </a:rPr>
-              <a:t>   white rice take 48.</a:t>
-            </a:r>
-          </a:p>
-          <a:p>
-            <a:pPr>
-              <a:lnSpc>
-                <a:spcPct val="135000"/>
-              </a:lnSpc>
-            </a:pPr>
-            <a:r>
-              <a:rPr sz="1300" b="0" i="0">
-                <a:solidFill>
-                  <a:srgbClr val="1B1B19"/>
-                </a:solidFill>
-                <a:latin typeface="IBM Plex Sans"/>
-              </a:rPr>
-              <a:t/>
-            </a:r>
-          </a:p>
-          <a:p>
-            <a:pPr>
-              <a:lnSpc>
-                <a:spcPct val="135000"/>
-              </a:lnSpc>
-            </a:pPr>
-            <a:r>
-              <a:rPr sz="1300" b="0" i="0">
-                <a:solidFill>
-                  <a:srgbClr val="1B1B19"/>
-                </a:solidFill>
-                <a:latin typeface="IBM Plex Sans"/>
-              </a:rPr>
-              <a:t>•  Together: peak 57 mg/dL lower and 40 minutes</a:t>
-            </a:r>
-          </a:p>
-          <a:p>
-            <a:pPr>
-              <a:lnSpc>
-                <a:spcPct val="135000"/>
-              </a:lnSpc>
-            </a:pPr>
-            <a:r>
-              <a:rPr sz="1300" b="0" i="0">
-                <a:solidFill>
-                  <a:srgbClr val="1B1B19"/>
-                </a:solidFill>
-                <a:latin typeface="IBM Plex Sans"/>
-              </a:rPr>
-              <a:t>   less above 180.</a:t>
-            </a:r>
-          </a:p>
-          <a:p>
-            <a:pPr>
-              <a:lnSpc>
-                <a:spcPct val="135000"/>
-              </a:lnSpc>
-            </a:pPr>
-            <a:r>
-              <a:rPr sz="1300" b="0" i="0">
-                <a:solidFill>
-                  <a:srgbClr val="1B1B19"/>
-                </a:solidFill>
-                <a:latin typeface="IBM Plex Sans"/>
-              </a:rPr>
-              <a:t/>
-            </a:r>
-          </a:p>
-          <a:p>
-            <a:pPr>
-              <a:lnSpc>
-                <a:spcPct val="135000"/>
-              </a:lnSpc>
-            </a:pPr>
-            <a:r>
-              <a:rPr sz="1300" b="0" i="0">
-                <a:solidFill>
-                  <a:srgbClr val="1B1B19"/>
-                </a:solidFill>
-                <a:latin typeface="IBM Plex Sans"/>
-              </a:rPr>
-              <a:t>•  Moving dinner earlier barely changes the peak</a:t>
-            </a:r>
-          </a:p>
-          <a:p>
-            <a:pPr>
-              <a:lnSpc>
-                <a:spcPct val="135000"/>
-              </a:lnSpc>
-            </a:pPr>
-            <a:r>
-              <a:rPr sz="1300" b="0" i="0">
-                <a:solidFill>
-                  <a:srgbClr val="1B1B19"/>
-                </a:solidFill>
-                <a:latin typeface="IBM Plex Sans"/>
-              </a:rPr>
-              <a:t>   tonight (it can only move to 19:50). The twin</a:t>
-            </a:r>
-          </a:p>
-          <a:p>
-            <a:pPr>
-              <a:lnSpc>
-                <a:spcPct val="135000"/>
-              </a:lnSpc>
-            </a:pPr>
-            <a:r>
-              <a:rPr sz="1300" b="0" i="0">
-                <a:solidFill>
-                  <a:srgbClr val="1B1B19"/>
-                </a:solidFill>
-                <a:latin typeface="IBM Plex Sans"/>
-              </a:rPr>
-              <a:t>   can say no.</a:t>
+            <a:off x="822960" y="5440680"/>
+            <a:ext cx="10607040" cy="734377"/>
+          </a:xfrm>
+          <a:prstGeom prst="rect">
+            <a:avLst/>
+          </a:prstGeom>
+          <a:noFill/>
+        </p:spPr>
+        <p:txBody>
+          <a:bodyPr wrap="none" lIns="0" rIns="0" tIns="0" bIns="0">
+            <a:spAutoFit/>
+          </a:bodyPr>
+          <a:lstStyle/>
+          <a:p>
+            <a:pPr>
+              <a:lnSpc>
+                <a:spcPct val="135000"/>
+              </a:lnSpc>
+            </a:pPr>
+            <a:r>
+              <a:rPr sz="1250" b="0" i="0">
+                <a:solidFill>
+                  <a:srgbClr val="4A4843"/>
+                </a:solidFill>
+                <a:latin typeface="IBM Plex Sans"/>
+              </a:rPr>
+              <a:t>CGMacros (PhysioNet, open access): 45 adults, Dexcom G6, meals with known carbohydrate. Trained only on synthetic data, the hybrid lands near</a:t>
+            </a:r>
+          </a:p>
+          <a:p>
+            <a:pPr>
+              <a:lnSpc>
+                <a:spcPct val="135000"/>
+              </a:lnSpc>
+            </a:pPr>
+            <a:r>
+              <a:rPr sz="1250" b="0" i="0">
+                <a:solidFill>
+                  <a:srgbClr val="4A4843"/>
+                </a:solidFill>
+                <a:latin typeface="IBM Plex Sans"/>
+              </a:rPr>
+              <a:t>persistence (36.7 against 38.3 mg/dL at 2 h). Told about meals in advance, the calibrated twin reaches 29.6. Interval coverage recovers from</a:t>
+            </a:r>
+          </a:p>
+          <a:p>
+            <a:pPr>
+              <a:lnSpc>
+                <a:spcPct val="135000"/>
+              </a:lnSpc>
+            </a:pPr>
+            <a:r>
+              <a:rPr sz="1250" b="0" i="0">
+                <a:solidFill>
+                  <a:srgbClr val="4A4843"/>
+                </a:solidFill>
+                <a:latin typeface="IBM Plex Sans"/>
+              </a:rPr>
+              <a:t>78% to 88% after per site recalibration.</a:t>
             </a:r>
           </a:p>
         </p:txBody>
@@ -4107,11 +4004,11 @@
             <a:r>
               <a:rPr sz="1000" b="0" i="0">
                 <a:solidFill>
-                  <a:srgbClr val="75726B"/>
-                </a:solidFill>
-                <a:latin typeface="IBM Plex Sans"/>
-              </a:rPr>
-              <a:t>USE</a:t>
+                  <a:srgbClr val="6A675F"/>
+                </a:solidFill>
+                <a:latin typeface="IBM Plex Sans"/>
+              </a:rPr>
+              <a:t>CASE STUDY</a:t>
             </a:r>
           </a:p>
         </p:txBody>
@@ -4150,7 +4047,7 @@
                 </a:solidFill>
                 <a:latin typeface="IBM Plex Serif"/>
               </a:rPr>
-              <a:t>Clinical workflow</a:t>
+              <a:t>What if: Ramesh, 52, night shift, T2D</a:t>
             </a:r>
           </a:p>
         </p:txBody>
@@ -4220,7 +4117,7 @@
             <a:r>
               <a:rPr sz="900" b="0" i="0">
                 <a:solidFill>
-                  <a:srgbClr val="75726B"/>
+                  <a:srgbClr val="6A675F"/>
                 </a:solidFill>
                 <a:latin typeface="IBM Plex Sans"/>
               </a:rPr>
@@ -4231,7 +4128,7 @@
       </p:sp>
       <p:pic>
         <p:nvPicPr>
-          <p:cNvPr id="6" name="Picture 5" descr="01_ward.png"/>
+          <p:cNvPr id="6" name="Picture 5" descr="03_whatif_ramesh.png"/>
           <p:cNvPicPr>
             <a:picLocks noChangeAspect="1"/>
           </p:cNvPicPr>
@@ -4246,7 +4143,7 @@
         <p:spPr>
           <a:xfrm>
             <a:off x="548640" y="1325880"/>
-            <a:ext cx="5486400" cy="3511296"/>
+            <a:ext cx="6943725" cy="4443984"/>
           </a:xfrm>
           <a:prstGeom prst="rect">
             <a:avLst/>
@@ -4258,141 +4155,249 @@
           </a:ln>
         </p:spPr>
       </p:pic>
-      <p:pic>
-        <p:nvPicPr>
-          <p:cNvPr id="7" name="Picture 6" descr="06_note_ramesh.png"/>
-          <p:cNvPicPr>
-            <a:picLocks noChangeAspect="1"/>
-          </p:cNvPicPr>
-          <p:nvPr/>
-        </p:nvPicPr>
-        <p:blipFill>
-          <a:blip r:embed="rId3"/>
-          <a:stretch>
-            <a:fillRect/>
-          </a:stretch>
-        </p:blipFill>
-        <p:spPr>
-          <a:xfrm>
-            <a:off x="6263640" y="1325880"/>
-            <a:ext cx="5178751" cy="3694176"/>
-          </a:xfrm>
-          <a:prstGeom prst="rect">
-            <a:avLst/>
-          </a:prstGeom>
-          <a:ln w="9525">
-            <a:solidFill>
-              <a:srgbClr val="D8D3C8"/>
-            </a:solidFill>
-          </a:ln>
-        </p:spPr>
-      </p:pic>
-      <p:sp>
-        <p:nvSpPr>
-          <p:cNvPr id="8" name="TextBox 7"/>
-          <p:cNvSpPr txBox="1"/>
-          <p:nvPr/>
-        </p:nvSpPr>
-        <p:spPr>
-          <a:xfrm>
-            <a:off x="548640" y="5074920"/>
-            <a:ext cx="5486400" cy="502920"/>
-          </a:xfrm>
-          <a:prstGeom prst="rect">
-            <a:avLst/>
-          </a:prstGeom>
-          <a:noFill/>
-        </p:spPr>
-        <p:txBody>
-          <a:bodyPr wrap="none" lIns="0" rIns="0" tIns="0" bIns="0">
-            <a:spAutoFit/>
-          </a:bodyPr>
-          <a:lstStyle/>
-          <a:p>
-            <a:pPr>
-              <a:lnSpc>
-                <a:spcPct val="135000"/>
-              </a:lnSpc>
-            </a:pPr>
-            <a:r>
-              <a:rPr sz="1200" b="0" i="0">
-                <a:solidFill>
-                  <a:srgbClr val="4A4843"/>
-                </a:solidFill>
-                <a:latin typeface="IBM Plex Sans"/>
-              </a:rPr>
-              <a:t>1. Ward list sorted by alerts, cardiovascular flags and forecast peak. 2.</a:t>
-            </a:r>
-          </a:p>
-          <a:p>
-            <a:pPr>
-              <a:lnSpc>
-                <a:spcPct val="135000"/>
-              </a:lnSpc>
-            </a:pPr>
-            <a:r>
-              <a:rPr sz="1200" b="0" i="0">
-                <a:solidFill>
-                  <a:srgbClr val="4A4843"/>
-                </a:solidFill>
-                <a:latin typeface="IBM Plex Sans"/>
-              </a:rPr>
-              <a:t>Open the twin: forecast band, reasons, alert log, AGP.</a:t>
-            </a:r>
-          </a:p>
-        </p:txBody>
-      </p:sp>
-      <p:sp>
-        <p:nvSpPr>
-          <p:cNvPr id="9" name="TextBox 8"/>
-          <p:cNvSpPr txBox="1"/>
-          <p:nvPr/>
-        </p:nvSpPr>
-        <p:spPr>
-          <a:xfrm>
-            <a:off x="6263640" y="5212080"/>
-            <a:ext cx="5394960" cy="502920"/>
-          </a:xfrm>
-          <a:prstGeom prst="rect">
-            <a:avLst/>
-          </a:prstGeom>
-          <a:noFill/>
-        </p:spPr>
-        <p:txBody>
-          <a:bodyPr wrap="none" lIns="0" rIns="0" tIns="0" bIns="0">
-            <a:spAutoFit/>
-          </a:bodyPr>
-          <a:lstStyle/>
-          <a:p>
-            <a:pPr>
-              <a:lnSpc>
-                <a:spcPct val="135000"/>
-              </a:lnSpc>
-            </a:pPr>
-            <a:r>
-              <a:rPr sz="1200" b="0" i="0">
-                <a:solidFill>
-                  <a:srgbClr val="4A4843"/>
-                </a:solidFill>
-                <a:latin typeface="IBM Plex Sans"/>
-              </a:rPr>
-              <a:t>3. Try what if with the patient. 4. One click SOAP note, printable or PDF,</a:t>
-            </a:r>
-          </a:p>
-          <a:p>
-            <a:pPr>
-              <a:lnSpc>
-                <a:spcPct val="135000"/>
-              </a:lnSpc>
-            </a:pPr>
-            <a:r>
-              <a:rPr sz="1200" b="0" i="0">
-                <a:solidFill>
-                  <a:srgbClr val="4A4843"/>
-                </a:solidFill>
-                <a:latin typeface="IBM Plex Sans"/>
-              </a:rPr>
-              <a:t>for the record.</a:t>
+      <p:sp>
+        <p:nvSpPr>
+          <p:cNvPr id="7" name="TextBox 6"/>
+          <p:cNvSpPr txBox="1"/>
+          <p:nvPr/>
+        </p:nvSpPr>
+        <p:spPr>
+          <a:xfrm>
+            <a:off x="7863840" y="1463040"/>
+            <a:ext cx="3840480" cy="3211830"/>
+          </a:xfrm>
+          <a:prstGeom prst="rect">
+            <a:avLst/>
+          </a:prstGeom>
+          <a:noFill/>
+        </p:spPr>
+        <p:txBody>
+          <a:bodyPr wrap="none" lIns="0" rIns="0" tIns="0" bIns="0">
+            <a:spAutoFit/>
+          </a:bodyPr>
+          <a:lstStyle/>
+          <a:p>
+            <a:pPr>
+              <a:lnSpc>
+                <a:spcPct val="135000"/>
+              </a:lnSpc>
+            </a:pPr>
+            <a:r>
+              <a:rPr sz="1300" b="0" i="0">
+                <a:solidFill>
+                  <a:srgbClr val="1B1B19"/>
+                </a:solidFill>
+                <a:latin typeface="IBM Plex Sans"/>
+              </a:rPr>
+              <a:t>•  19:45. The hybrid forecast expects dinner at</a:t>
+            </a:r>
+          </a:p>
+          <a:p>
+            <a:pPr>
+              <a:lnSpc>
+                <a:spcPct val="135000"/>
+              </a:lnSpc>
+            </a:pPr>
+            <a:r>
+              <a:rPr sz="1300" b="0" i="0">
+                <a:solidFill>
+                  <a:srgbClr val="1B1B19"/>
+                </a:solidFill>
+                <a:latin typeface="IBM Plex Sans"/>
+              </a:rPr>
+              <a:t>   20:15 and a peak near 278 mg/dL, after three</a:t>
+            </a:r>
+          </a:p>
+          <a:p>
+            <a:pPr>
+              <a:lnSpc>
+                <a:spcPct val="135000"/>
+              </a:lnSpc>
+            </a:pPr>
+            <a:r>
+              <a:rPr sz="1300" b="0" i="0">
+                <a:solidFill>
+                  <a:srgbClr val="1B1B19"/>
+                </a:solidFill>
+                <a:latin typeface="IBM Plex Sans"/>
+              </a:rPr>
+              <a:t>   nights of 4.9 h sleep.</a:t>
+            </a:r>
+          </a:p>
+          <a:p>
+            <a:pPr>
+              <a:lnSpc>
+                <a:spcPct val="135000"/>
+              </a:lnSpc>
+            </a:pPr>
+            <a:r>
+              <a:rPr sz="1300" b="0" i="0">
+                <a:solidFill>
+                  <a:srgbClr val="1B1B19"/>
+                </a:solidFill>
+                <a:latin typeface="IBM Plex Sans"/>
+              </a:rPr>
+              <a:t/>
+            </a:r>
+          </a:p>
+          <a:p>
+            <a:pPr>
+              <a:lnSpc>
+                <a:spcPct val="135000"/>
+              </a:lnSpc>
+            </a:pPr>
+            <a:r>
+              <a:rPr sz="1300" b="0" i="0">
+                <a:solidFill>
+                  <a:srgbClr val="1B1B19"/>
+                </a:solidFill>
+                <a:latin typeface="IBM Plex Sans"/>
+              </a:rPr>
+              <a:t>•  A 15 minute walk after dinner takes 15 mg/dL</a:t>
+            </a:r>
+          </a:p>
+          <a:p>
+            <a:pPr>
+              <a:lnSpc>
+                <a:spcPct val="135000"/>
+              </a:lnSpc>
+            </a:pPr>
+            <a:r>
+              <a:rPr sz="1300" b="0" i="0">
+                <a:solidFill>
+                  <a:srgbClr val="1B1B19"/>
+                </a:solidFill>
+                <a:latin typeface="IBM Plex Sans"/>
+              </a:rPr>
+              <a:t>   off the twin's 6 hour peak. Millets instead of</a:t>
+            </a:r>
+          </a:p>
+          <a:p>
+            <a:pPr>
+              <a:lnSpc>
+                <a:spcPct val="135000"/>
+              </a:lnSpc>
+            </a:pPr>
+            <a:r>
+              <a:rPr sz="1300" b="0" i="0">
+                <a:solidFill>
+                  <a:srgbClr val="1B1B19"/>
+                </a:solidFill>
+                <a:latin typeface="IBM Plex Sans"/>
+              </a:rPr>
+              <a:t>   white rice take 48.</a:t>
+            </a:r>
+          </a:p>
+          <a:p>
+            <a:pPr>
+              <a:lnSpc>
+                <a:spcPct val="135000"/>
+              </a:lnSpc>
+            </a:pPr>
+            <a:r>
+              <a:rPr sz="1300" b="0" i="0">
+                <a:solidFill>
+                  <a:srgbClr val="1B1B19"/>
+                </a:solidFill>
+                <a:latin typeface="IBM Plex Sans"/>
+              </a:rPr>
+              <a:t/>
+            </a:r>
+          </a:p>
+          <a:p>
+            <a:pPr>
+              <a:lnSpc>
+                <a:spcPct val="135000"/>
+              </a:lnSpc>
+            </a:pPr>
+            <a:r>
+              <a:rPr sz="1300" b="0" i="0">
+                <a:solidFill>
+                  <a:srgbClr val="1B1B19"/>
+                </a:solidFill>
+                <a:latin typeface="IBM Plex Sans"/>
+              </a:rPr>
+              <a:t>•  Together: peak 57 mg/dL lower and 40 minutes</a:t>
+            </a:r>
+          </a:p>
+          <a:p>
+            <a:pPr>
+              <a:lnSpc>
+                <a:spcPct val="135000"/>
+              </a:lnSpc>
+            </a:pPr>
+            <a:r>
+              <a:rPr sz="1300" b="0" i="0">
+                <a:solidFill>
+                  <a:srgbClr val="1B1B19"/>
+                </a:solidFill>
+                <a:latin typeface="IBM Plex Sans"/>
+              </a:rPr>
+              <a:t>   less above 180.</a:t>
+            </a:r>
+          </a:p>
+          <a:p>
+            <a:pPr>
+              <a:lnSpc>
+                <a:spcPct val="135000"/>
+              </a:lnSpc>
+            </a:pPr>
+            <a:r>
+              <a:rPr sz="1300" b="0" i="0">
+                <a:solidFill>
+                  <a:srgbClr val="1B1B19"/>
+                </a:solidFill>
+                <a:latin typeface="IBM Plex Sans"/>
+              </a:rPr>
+              <a:t/>
+            </a:r>
+          </a:p>
+          <a:p>
+            <a:pPr>
+              <a:lnSpc>
+                <a:spcPct val="135000"/>
+              </a:lnSpc>
+            </a:pPr>
+            <a:r>
+              <a:rPr sz="1300" b="0" i="0">
+                <a:solidFill>
+                  <a:srgbClr val="1B1B19"/>
+                </a:solidFill>
+                <a:latin typeface="IBM Plex Sans"/>
+              </a:rPr>
+              <a:t>•  Moving dinner earlier barely changes the peak</a:t>
+            </a:r>
+          </a:p>
+          <a:p>
+            <a:pPr>
+              <a:lnSpc>
+                <a:spcPct val="135000"/>
+              </a:lnSpc>
+            </a:pPr>
+            <a:r>
+              <a:rPr sz="1300" b="0" i="0">
+                <a:solidFill>
+                  <a:srgbClr val="1B1B19"/>
+                </a:solidFill>
+                <a:latin typeface="IBM Plex Sans"/>
+              </a:rPr>
+              <a:t>   tonight (it can only move to 19:50). The twin</a:t>
+            </a:r>
+          </a:p>
+          <a:p>
+            <a:pPr>
+              <a:lnSpc>
+                <a:spcPct val="135000"/>
+              </a:lnSpc>
+            </a:pPr>
+            <a:r>
+              <a:rPr sz="1300" b="0" i="0">
+                <a:solidFill>
+                  <a:srgbClr val="1B1B19"/>
+                </a:solidFill>
+                <a:latin typeface="IBM Plex Sans"/>
+              </a:rPr>
+              <a:t>   can say no.</a:t>
             </a:r>
           </a:p>
         </p:txBody>
@@ -4453,11 +4458,11 @@
             <a:r>
               <a:rPr sz="1000" b="0" i="0">
                 <a:solidFill>
-                  <a:srgbClr val="75726B"/>
-                </a:solidFill>
-                <a:latin typeface="IBM Plex Sans"/>
-              </a:rPr>
-              <a:t>GOVERNANCE</a:t>
+                  <a:srgbClr val="6A675F"/>
+                </a:solidFill>
+                <a:latin typeface="IBM Plex Sans"/>
+              </a:rPr>
+              <a:t>USE</a:t>
             </a:r>
           </a:p>
         </p:txBody>
@@ -4496,7 +4501,7 @@
                 </a:solidFill>
                 <a:latin typeface="IBM Plex Serif"/>
               </a:rPr>
-              <a:t>Privacy, safety and limits</a:t>
+              <a:t>Clinical workflow</a:t>
             </a:r>
           </a:p>
         </p:txBody>
@@ -4566,7 +4571,7 @@
             <a:r>
               <a:rPr sz="900" b="0" i="0">
                 <a:solidFill>
-                  <a:srgbClr val="75726B"/>
+                  <a:srgbClr val="6A675F"/>
                 </a:solidFill>
                 <a:latin typeface="IBM Plex Sans"/>
               </a:rPr>
@@ -4575,240 +4580,64 @@
           </a:p>
         </p:txBody>
       </p:sp>
-      <p:sp>
-        <p:nvSpPr>
-          <p:cNvPr id="6" name="TextBox 5"/>
-          <p:cNvSpPr txBox="1"/>
-          <p:nvPr/>
-        </p:nvSpPr>
-        <p:spPr>
-          <a:xfrm>
-            <a:off x="822960" y="1600200"/>
-            <a:ext cx="5120640" cy="2637472"/>
-          </a:xfrm>
-          <a:prstGeom prst="rect">
-            <a:avLst/>
-          </a:prstGeom>
-          <a:noFill/>
-        </p:spPr>
-        <p:txBody>
-          <a:bodyPr wrap="none" lIns="0" rIns="0" tIns="0" bIns="0">
-            <a:spAutoFit/>
-          </a:bodyPr>
-          <a:lstStyle/>
-          <a:p>
-            <a:pPr>
-              <a:lnSpc>
-                <a:spcPct val="135000"/>
-              </a:lnSpc>
-            </a:pPr>
-            <a:r>
-              <a:rPr sz="1350" b="0" i="0">
-                <a:solidFill>
-                  <a:srgbClr val="1B1B19"/>
-                </a:solidFill>
-                <a:latin typeface="IBM Plex Sans"/>
-              </a:rPr>
-              <a:t>•  Synthetic data only: no personal data under the DPDP Act</a:t>
-            </a:r>
-          </a:p>
-          <a:p>
-            <a:pPr>
-              <a:lnSpc>
-                <a:spcPct val="135000"/>
-              </a:lnSpc>
-            </a:pPr>
-            <a:r>
-              <a:rPr sz="1350" b="0" i="0">
-                <a:solidFill>
-                  <a:srgbClr val="1B1B19"/>
-                </a:solidFill>
-                <a:latin typeface="IBM Plex Sans"/>
-              </a:rPr>
-              <a:t>   2023 or HIPAA was used.</a:t>
-            </a:r>
-          </a:p>
-          <a:p>
-            <a:pPr>
-              <a:lnSpc>
-                <a:spcPct val="135000"/>
-              </a:lnSpc>
-            </a:pPr>
-            <a:r>
-              <a:rPr sz="1350" b="0" i="0">
-                <a:solidFill>
-                  <a:srgbClr val="1B1B19"/>
-                </a:solidFill>
-                <a:latin typeface="IBM Plex Sans"/>
-              </a:rPr>
-              <a:t/>
-            </a:r>
-          </a:p>
-          <a:p>
-            <a:pPr>
-              <a:lnSpc>
-                <a:spcPct val="135000"/>
-              </a:lnSpc>
-            </a:pPr>
-            <a:r>
-              <a:rPr sz="1350" b="0" i="0">
-                <a:solidFill>
-                  <a:srgbClr val="1B1B19"/>
-                </a:solidFill>
-                <a:latin typeface="IBM Plex Sans"/>
-              </a:rPr>
-              <a:t>•  Each record carries a consent artefact: purpose limited,</a:t>
-            </a:r>
-          </a:p>
-          <a:p>
-            <a:pPr>
-              <a:lnSpc>
-                <a:spcPct val="135000"/>
-              </a:lnSpc>
-            </a:pPr>
-            <a:r>
-              <a:rPr sz="1350" b="0" i="0">
-                <a:solidFill>
-                  <a:srgbClr val="1B1B19"/>
-                </a:solidFill>
-                <a:latin typeface="IBM Plex Sans"/>
-              </a:rPr>
-              <a:t>   time bound, revocable.</a:t>
-            </a:r>
-          </a:p>
-          <a:p>
-            <a:pPr>
-              <a:lnSpc>
-                <a:spcPct val="135000"/>
-              </a:lnSpc>
-            </a:pPr>
-            <a:r>
-              <a:rPr sz="1350" b="0" i="0">
-                <a:solidFill>
-                  <a:srgbClr val="1B1B19"/>
-                </a:solidFill>
-                <a:latin typeface="IBM Plex Sans"/>
-              </a:rPr>
-              <a:t/>
-            </a:r>
-          </a:p>
-          <a:p>
-            <a:pPr>
-              <a:lnSpc>
-                <a:spcPct val="135000"/>
-              </a:lnSpc>
-            </a:pPr>
-            <a:r>
-              <a:rPr sz="1350" b="0" i="0">
-                <a:solidFill>
-                  <a:srgbClr val="1B1B19"/>
-                </a:solidFill>
-                <a:latin typeface="IBM Plex Sans"/>
-              </a:rPr>
-              <a:t>•  Deployment design: on premises inference, no identifiers in</a:t>
-            </a:r>
-          </a:p>
-          <a:p>
-            <a:pPr>
-              <a:lnSpc>
-                <a:spcPct val="135000"/>
-              </a:lnSpc>
-            </a:pPr>
-            <a:r>
-              <a:rPr sz="1350" b="0" i="0">
-                <a:solidFill>
-                  <a:srgbClr val="1B1B19"/>
-                </a:solidFill>
-                <a:latin typeface="IBM Plex Sans"/>
-              </a:rPr>
-              <a:t>   model features, audit log, ABDM consent flow.</a:t>
-            </a:r>
-          </a:p>
-          <a:p>
-            <a:pPr>
-              <a:lnSpc>
-                <a:spcPct val="135000"/>
-              </a:lnSpc>
-            </a:pPr>
-            <a:r>
-              <a:rPr sz="1350" b="0" i="0">
-                <a:solidFill>
-                  <a:srgbClr val="1B1B19"/>
-                </a:solidFill>
-                <a:latin typeface="IBM Plex Sans"/>
-              </a:rPr>
-              <a:t/>
-            </a:r>
-          </a:p>
-          <a:p>
-            <a:pPr>
-              <a:lnSpc>
-                <a:spcPct val="135000"/>
-              </a:lnSpc>
-            </a:pPr>
-            <a:r>
-              <a:rPr sz="1350" b="0" i="0">
-                <a:solidFill>
-                  <a:srgbClr val="1B1B19"/>
-                </a:solidFill>
-                <a:latin typeface="IBM Plex Sans"/>
-              </a:rPr>
-              <a:t>•  Decision support only, not a diagnosis. The clinician</a:t>
-            </a:r>
-          </a:p>
-          <a:p>
-            <a:pPr>
-              <a:lnSpc>
-                <a:spcPct val="135000"/>
-              </a:lnSpc>
-            </a:pPr>
-            <a:r>
-              <a:rPr sz="1350" b="0" i="0">
-                <a:solidFill>
-                  <a:srgbClr val="1B1B19"/>
-                </a:solidFill>
-                <a:latin typeface="IBM Plex Sans"/>
-              </a:rPr>
-              <a:t>   decides.</a:t>
-            </a:r>
-          </a:p>
-        </p:txBody>
-      </p:sp>
-      <p:cxnSp>
-        <p:nvCxnSpPr>
-          <p:cNvPr id="7" name="Connector 6"/>
-          <p:cNvCxnSpPr/>
-          <p:nvPr/>
-        </p:nvCxnSpPr>
-        <p:spPr>
-          <a:xfrm>
-            <a:off x="6400800" y="1645920"/>
-            <a:ext cx="5029200" cy="0"/>
-          </a:xfrm>
-          <a:prstGeom prst="line">
-            <a:avLst/>
-          </a:prstGeom>
-          <a:ln w="10160">
+      <p:pic>
+        <p:nvPicPr>
+          <p:cNvPr id="6" name="Picture 5" descr="01_ward.png"/>
+          <p:cNvPicPr>
+            <a:picLocks noChangeAspect="1"/>
+          </p:cNvPicPr>
+          <p:nvPr/>
+        </p:nvPicPr>
+        <p:blipFill>
+          <a:blip r:embed="rId2"/>
+          <a:stretch>
+            <a:fillRect/>
+          </a:stretch>
+        </p:blipFill>
+        <p:spPr>
+          <a:xfrm>
+            <a:off x="548640" y="1325880"/>
+            <a:ext cx="5486400" cy="3511296"/>
+          </a:xfrm>
+          <a:prstGeom prst="rect">
+            <a:avLst/>
+          </a:prstGeom>
+          <a:ln w="9525">
             <a:solidFill>
               <a:srgbClr val="D8D3C8"/>
             </a:solidFill>
           </a:ln>
         </p:spPr>
-        <p:style>
-          <a:lnRef idx="2">
-            <a:schemeClr val="accent1"/>
-          </a:lnRef>
-          <a:fillRef idx="0">
-            <a:schemeClr val="accent1"/>
-          </a:fillRef>
-          <a:effectRef idx="1">
-            <a:schemeClr val="accent1"/>
-          </a:effectRef>
-          <a:fontRef idx="minor">
-            <a:schemeClr val="tx1"/>
-          </a:fontRef>
-        </p:style>
-      </p:cxnSp>
+      </p:pic>
+      <p:pic>
+        <p:nvPicPr>
+          <p:cNvPr id="7" name="Picture 6" descr="06_note_ramesh.png"/>
+          <p:cNvPicPr>
+            <a:picLocks noChangeAspect="1"/>
+          </p:cNvPicPr>
+          <p:nvPr/>
+        </p:nvPicPr>
+        <p:blipFill>
+          <a:blip r:embed="rId3"/>
+          <a:stretch>
+            <a:fillRect/>
+          </a:stretch>
+        </p:blipFill>
+        <p:spPr>
+          <a:xfrm>
+            <a:off x="6263640" y="1325880"/>
+            <a:ext cx="5191690" cy="3694176"/>
+          </a:xfrm>
+          <a:prstGeom prst="rect">
+            <a:avLst/>
+          </a:prstGeom>
+          <a:ln w="9525">
+            <a:solidFill>
+              <a:srgbClr val="D8D3C8"/>
+            </a:solidFill>
+          </a:ln>
+        </p:spPr>
+      </p:pic>
       <p:sp>
         <p:nvSpPr>
           <p:cNvPr id="8" name="TextBox 7"/>
@@ -4817,33 +4646,65 @@
         </p:nvSpPr>
         <p:spPr>
           <a:xfrm>
-            <a:off x="6400800" y="1783080"/>
-            <a:ext cx="5029200" cy="365760"/>
-          </a:xfrm>
-          <a:prstGeom prst="rect">
-            <a:avLst/>
-          </a:prstGeom>
-          <a:noFill/>
-        </p:spPr>
-        <p:txBody>
-          <a:bodyPr wrap="none" lIns="0" rIns="0" tIns="0" bIns="0">
-            <a:spAutoFit/>
-          </a:bodyPr>
-          <a:lstStyle/>
-          <a:p>
-            <a:pPr>
-              <a:lnSpc>
-                <a:spcPct val="135000"/>
-              </a:lnSpc>
-            </a:pPr>
-            <a:r>
-              <a:rPr sz="1400" b="0" i="0">
-                <a:solidFill>
-                  <a:srgbClr val="1B1B19"/>
-                </a:solidFill>
-                <a:latin typeface="IBM Plex Serif"/>
-              </a:rPr>
-              <a:t>Limitations we state openly</a:t>
+            <a:off x="548640" y="5074920"/>
+            <a:ext cx="5486400" cy="708660"/>
+          </a:xfrm>
+          <a:prstGeom prst="rect">
+            <a:avLst/>
+          </a:prstGeom>
+          <a:noFill/>
+        </p:spPr>
+        <p:txBody>
+          <a:bodyPr wrap="none" lIns="0" rIns="0" tIns="0" bIns="0">
+            <a:spAutoFit/>
+          </a:bodyPr>
+          <a:lstStyle/>
+          <a:p>
+            <a:pPr>
+              <a:lnSpc>
+                <a:spcPct val="135000"/>
+              </a:lnSpc>
+            </a:pPr>
+            <a:r>
+              <a:rPr sz="1200" b="0" i="0">
+                <a:solidFill>
+                  <a:srgbClr val="4A4843"/>
+                </a:solidFill>
+                <a:latin typeface="IBM Plex Sans"/>
+              </a:rPr>
+              <a:t>1. Ward sorted by alerts, with what changed since the last look; acknowledge</a:t>
+            </a:r>
+          </a:p>
+          <a:p>
+            <a:pPr>
+              <a:lnSpc>
+                <a:spcPct val="135000"/>
+              </a:lnSpc>
+            </a:pPr>
+            <a:r>
+              <a:rPr sz="1200" b="0" i="0">
+                <a:solidFill>
+                  <a:srgbClr val="4A4843"/>
+                </a:solidFill>
+                <a:latin typeface="IBM Plex Sans"/>
+              </a:rPr>
+              <a:t>and snooze, with an audit trail. 2. Open the twin: forecast band, reasons,</a:t>
+            </a:r>
+          </a:p>
+          <a:p>
+            <a:pPr>
+              <a:lnSpc>
+                <a:spcPct val="135000"/>
+              </a:lnSpc>
+            </a:pPr>
+            <a:r>
+              <a:rPr sz="1200" b="0" i="0">
+                <a:solidFill>
+                  <a:srgbClr val="4A4843"/>
+                </a:solidFill>
+                <a:latin typeface="IBM Plex Sans"/>
+              </a:rPr>
+              <a:t>alert log, AGP; tell it about tonight's meal.</a:t>
             </a:r>
           </a:p>
         </p:txBody>
@@ -4856,161 +4717,49 @@
         </p:nvSpPr>
         <p:spPr>
           <a:xfrm>
-            <a:off x="6400800" y="2286000"/>
-            <a:ext cx="5029200" cy="2097405"/>
-          </a:xfrm>
-          <a:prstGeom prst="rect">
-            <a:avLst/>
-          </a:prstGeom>
-          <a:noFill/>
-        </p:spPr>
-        <p:txBody>
-          <a:bodyPr wrap="none" lIns="0" rIns="0" tIns="0" bIns="0">
-            <a:spAutoFit/>
-          </a:bodyPr>
-          <a:lstStyle/>
-          <a:p>
-            <a:pPr>
-              <a:lnSpc>
-                <a:spcPct val="135000"/>
-              </a:lnSpc>
-            </a:pPr>
-            <a:r>
-              <a:rPr sz="1300" b="0" i="0">
+            <a:off x="6263640" y="5212080"/>
+            <a:ext cx="5394960" cy="502920"/>
+          </a:xfrm>
+          <a:prstGeom prst="rect">
+            <a:avLst/>
+          </a:prstGeom>
+          <a:noFill/>
+        </p:spPr>
+        <p:txBody>
+          <a:bodyPr wrap="none" lIns="0" rIns="0" tIns="0" bIns="0">
+            <a:spAutoFit/>
+          </a:bodyPr>
+          <a:lstStyle/>
+          <a:p>
+            <a:pPr>
+              <a:lnSpc>
+                <a:spcPct val="135000"/>
+              </a:lnSpc>
+            </a:pPr>
+            <a:r>
+              <a:rPr sz="1200" b="0" i="0">
                 <a:solidFill>
                   <a:srgbClr val="4A4843"/>
                 </a:solidFill>
                 <a:latin typeface="IBM Plex Sans"/>
               </a:rPr>
-              <a:t>•  Synthetic ground truth is still a model; real data will be</a:t>
-            </a:r>
-          </a:p>
-          <a:p>
-            <a:pPr>
-              <a:lnSpc>
-                <a:spcPct val="135000"/>
-              </a:lnSpc>
-            </a:pPr>
-            <a:r>
-              <a:rPr sz="1300" b="0" i="0">
+              <a:t>3. Rank the levers for this patient and share them in English, Hindi or</a:t>
+            </a:r>
+          </a:p>
+          <a:p>
+            <a:pPr>
+              <a:lnSpc>
+                <a:spcPct val="135000"/>
+              </a:lnSpc>
+            </a:pPr>
+            <a:r>
+              <a:rPr sz="1200" b="0" i="0">
                 <a:solidFill>
                   <a:srgbClr val="4A4843"/>
                 </a:solidFill>
                 <a:latin typeface="IBM Plex Sans"/>
               </a:rPr>
-              <a:t>   harder.</a:t>
-            </a:r>
-          </a:p>
-          <a:p>
-            <a:pPr>
-              <a:lnSpc>
-                <a:spcPct val="135000"/>
-              </a:lnSpc>
-            </a:pPr>
-            <a:r>
-              <a:rPr sz="1300" b="0" i="0">
-                <a:solidFill>
-                  <a:srgbClr val="4A4843"/>
-                </a:solidFill>
-                <a:latin typeface="IBM Plex Sans"/>
-              </a:rPr>
-              <a:t/>
-            </a:r>
-          </a:p>
-          <a:p>
-            <a:pPr>
-              <a:lnSpc>
-                <a:spcPct val="135000"/>
-              </a:lnSpc>
-            </a:pPr>
-            <a:r>
-              <a:rPr sz="1300" b="0" i="0">
-                <a:solidFill>
-                  <a:srgbClr val="4A4843"/>
-                </a:solidFill>
-                <a:latin typeface="IBM Plex Sans"/>
-              </a:rPr>
-              <a:t>•  Only 6 cardiovascular events in test patients.</a:t>
-            </a:r>
-          </a:p>
-          <a:p>
-            <a:pPr>
-              <a:lnSpc>
-                <a:spcPct val="135000"/>
-              </a:lnSpc>
-            </a:pPr>
-            <a:r>
-              <a:rPr sz="1300" b="0" i="0">
-                <a:solidFill>
-                  <a:srgbClr val="4A4843"/>
-                </a:solidFill>
-                <a:latin typeface="IBM Plex Sans"/>
-              </a:rPr>
-              <a:t/>
-            </a:r>
-          </a:p>
-          <a:p>
-            <a:pPr>
-              <a:lnSpc>
-                <a:spcPct val="135000"/>
-              </a:lnSpc>
-            </a:pPr>
-            <a:r>
-              <a:rPr sz="1300" b="0" i="0">
-                <a:solidFill>
-                  <a:srgbClr val="4A4843"/>
-                </a:solidFill>
-                <a:latin typeface="IBM Plex Sans"/>
-              </a:rPr>
-              <a:t>•  Conformal coverage is approximate with serially correlated</a:t>
-            </a:r>
-          </a:p>
-          <a:p>
-            <a:pPr>
-              <a:lnSpc>
-                <a:spcPct val="135000"/>
-              </a:lnSpc>
-            </a:pPr>
-            <a:r>
-              <a:rPr sz="1300" b="0" i="0">
-                <a:solidFill>
-                  <a:srgbClr val="4A4843"/>
-                </a:solidFill>
-                <a:latin typeface="IBM Plex Sans"/>
-              </a:rPr>
-              <a:t>   readings, and lower below 70 mg/dL.</a:t>
-            </a:r>
-          </a:p>
-          <a:p>
-            <a:pPr>
-              <a:lnSpc>
-                <a:spcPct val="135000"/>
-              </a:lnSpc>
-            </a:pPr>
-            <a:r>
-              <a:rPr sz="1300" b="0" i="0">
-                <a:solidFill>
-                  <a:srgbClr val="4A4843"/>
-                </a:solidFill>
-                <a:latin typeface="IBM Plex Sans"/>
-              </a:rPr>
-              <a:t/>
-            </a:r>
-          </a:p>
-          <a:p>
-            <a:pPr>
-              <a:lnSpc>
-                <a:spcPct val="135000"/>
-              </a:lnSpc>
-            </a:pPr>
-            <a:r>
-              <a:rPr sz="1300" b="0" i="0">
-                <a:solidFill>
-                  <a:srgbClr val="4A4843"/>
-                </a:solidFill>
-                <a:latin typeface="IBM Plex Sans"/>
-              </a:rPr>
-              <a:t>•  Unlogged meals remain the main source of missed spikes.</a:t>
+              <a:t>Tamil. 4. One click SOAP note for the record.</a:t>
             </a:r>
           </a:p>
         </p:txBody>
@@ -5071,11 +4820,11 @@
             <a:r>
               <a:rPr sz="1000" b="0" i="0">
                 <a:solidFill>
-                  <a:srgbClr val="75726B"/>
-                </a:solidFill>
-                <a:latin typeface="IBM Plex Sans"/>
-              </a:rPr>
-              <a:t>NEXT</a:t>
+                  <a:srgbClr val="6A675F"/>
+                </a:solidFill>
+                <a:latin typeface="IBM Plex Sans"/>
+              </a:rPr>
+              <a:t>GOVERNANCE</a:t>
             </a:r>
           </a:p>
         </p:txBody>
@@ -5114,7 +4863,7 @@
                 </a:solidFill>
                 <a:latin typeface="IBM Plex Serif"/>
               </a:rPr>
-              <a:t>Impact and roadmap</a:t>
+              <a:t>Privacy, safety and limits</a:t>
             </a:r>
           </a:p>
         </p:txBody>
@@ -5184,7 +4933,7 @@
             <a:r>
               <a:rPr sz="900" b="0" i="0">
                 <a:solidFill>
-                  <a:srgbClr val="75726B"/>
+                  <a:srgbClr val="6A675F"/>
                 </a:solidFill>
                 <a:latin typeface="IBM Plex Sans"/>
               </a:rPr>
@@ -5201,93 +4950,214 @@
         </p:nvSpPr>
         <p:spPr>
           <a:xfrm>
-            <a:off x="822960" y="1719072"/>
-            <a:ext cx="2103120" cy="365760"/>
-          </a:xfrm>
-          <a:prstGeom prst="rect">
-            <a:avLst/>
-          </a:prstGeom>
-          <a:noFill/>
-        </p:spPr>
-        <p:txBody>
-          <a:bodyPr wrap="none" lIns="0" rIns="0" tIns="0" bIns="0">
-            <a:spAutoFit/>
-          </a:bodyPr>
-          <a:lstStyle/>
-          <a:p>
-            <a:pPr>
-              <a:lnSpc>
-                <a:spcPct val="130000"/>
-              </a:lnSpc>
-            </a:pPr>
-            <a:r>
-              <a:rPr sz="1150" b="0" i="0">
-                <a:solidFill>
-                  <a:srgbClr val="75726B"/>
-                </a:solidFill>
-                <a:latin typeface="IBM Plex Sans"/>
-              </a:rPr>
-              <a:t>Now</a:t>
-            </a:r>
-          </a:p>
-        </p:txBody>
-      </p:sp>
-      <p:sp>
-        <p:nvSpPr>
-          <p:cNvPr id="7" name="TextBox 6"/>
-          <p:cNvSpPr txBox="1"/>
-          <p:nvPr/>
-        </p:nvSpPr>
-        <p:spPr>
-          <a:xfrm>
-            <a:off x="3017520" y="1719072"/>
-            <a:ext cx="8321040" cy="365760"/>
-          </a:xfrm>
-          <a:prstGeom prst="rect">
-            <a:avLst/>
-          </a:prstGeom>
-          <a:noFill/>
-        </p:spPr>
-        <p:txBody>
-          <a:bodyPr wrap="none" lIns="0" rIns="0" tIns="0" bIns="0">
-            <a:spAutoFit/>
-          </a:bodyPr>
-          <a:lstStyle/>
-          <a:p>
-            <a:pPr>
-              <a:lnSpc>
-                <a:spcPct val="130000"/>
-              </a:lnSpc>
-            </a:pPr>
-            <a:r>
-              <a:rPr sz="1150" b="0" i="0">
-                <a:solidFill>
-                  <a:srgbClr val="75726B"/>
-                </a:solidFill>
-                <a:latin typeface="IBM Plex Sans"/>
-              </a:rPr>
-              <a:t>Working prototype: data, twin, models, API, dashboard, tests, docs. Reproducible from one seed.</a:t>
+            <a:off x="822960" y="1600200"/>
+            <a:ext cx="5120640" cy="2637472"/>
+          </a:xfrm>
+          <a:prstGeom prst="rect">
+            <a:avLst/>
+          </a:prstGeom>
+          <a:noFill/>
+        </p:spPr>
+        <p:txBody>
+          <a:bodyPr wrap="none" lIns="0" rIns="0" tIns="0" bIns="0">
+            <a:spAutoFit/>
+          </a:bodyPr>
+          <a:lstStyle/>
+          <a:p>
+            <a:pPr>
+              <a:lnSpc>
+                <a:spcPct val="135000"/>
+              </a:lnSpc>
+            </a:pPr>
+            <a:r>
+              <a:rPr sz="1350" b="0" i="0">
+                <a:solidFill>
+                  <a:srgbClr val="1B1B19"/>
+                </a:solidFill>
+                <a:latin typeface="IBM Plex Sans"/>
+              </a:rPr>
+              <a:t>•  Synthetic data only: no personal data under the DPDP Act</a:t>
+            </a:r>
+          </a:p>
+          <a:p>
+            <a:pPr>
+              <a:lnSpc>
+                <a:spcPct val="135000"/>
+              </a:lnSpc>
+            </a:pPr>
+            <a:r>
+              <a:rPr sz="1350" b="0" i="0">
+                <a:solidFill>
+                  <a:srgbClr val="1B1B19"/>
+                </a:solidFill>
+                <a:latin typeface="IBM Plex Sans"/>
+              </a:rPr>
+              <a:t>   2023 or HIPAA was used.</a:t>
+            </a:r>
+          </a:p>
+          <a:p>
+            <a:pPr>
+              <a:lnSpc>
+                <a:spcPct val="135000"/>
+              </a:lnSpc>
+            </a:pPr>
+            <a:r>
+              <a:rPr sz="1350" b="0" i="0">
+                <a:solidFill>
+                  <a:srgbClr val="1B1B19"/>
+                </a:solidFill>
+                <a:latin typeface="IBM Plex Sans"/>
+              </a:rPr>
+              <a:t/>
+            </a:r>
+          </a:p>
+          <a:p>
+            <a:pPr>
+              <a:lnSpc>
+                <a:spcPct val="135000"/>
+              </a:lnSpc>
+            </a:pPr>
+            <a:r>
+              <a:rPr sz="1350" b="0" i="0">
+                <a:solidFill>
+                  <a:srgbClr val="1B1B19"/>
+                </a:solidFill>
+                <a:latin typeface="IBM Plex Sans"/>
+              </a:rPr>
+              <a:t>•  Each record carries a consent artefact: purpose limited,</a:t>
+            </a:r>
+          </a:p>
+          <a:p>
+            <a:pPr>
+              <a:lnSpc>
+                <a:spcPct val="135000"/>
+              </a:lnSpc>
+            </a:pPr>
+            <a:r>
+              <a:rPr sz="1350" b="0" i="0">
+                <a:solidFill>
+                  <a:srgbClr val="1B1B19"/>
+                </a:solidFill>
+                <a:latin typeface="IBM Plex Sans"/>
+              </a:rPr>
+              <a:t>   time bound, revocable.</a:t>
+            </a:r>
+          </a:p>
+          <a:p>
+            <a:pPr>
+              <a:lnSpc>
+                <a:spcPct val="135000"/>
+              </a:lnSpc>
+            </a:pPr>
+            <a:r>
+              <a:rPr sz="1350" b="0" i="0">
+                <a:solidFill>
+                  <a:srgbClr val="1B1B19"/>
+                </a:solidFill>
+                <a:latin typeface="IBM Plex Sans"/>
+              </a:rPr>
+              <a:t/>
+            </a:r>
+          </a:p>
+          <a:p>
+            <a:pPr>
+              <a:lnSpc>
+                <a:spcPct val="135000"/>
+              </a:lnSpc>
+            </a:pPr>
+            <a:r>
+              <a:rPr sz="1350" b="0" i="0">
+                <a:solidFill>
+                  <a:srgbClr val="1B1B19"/>
+                </a:solidFill>
+                <a:latin typeface="IBM Plex Sans"/>
+              </a:rPr>
+              <a:t>•  Deployment design: on premises inference, no identifiers in</a:t>
+            </a:r>
+          </a:p>
+          <a:p>
+            <a:pPr>
+              <a:lnSpc>
+                <a:spcPct val="135000"/>
+              </a:lnSpc>
+            </a:pPr>
+            <a:r>
+              <a:rPr sz="1350" b="0" i="0">
+                <a:solidFill>
+                  <a:srgbClr val="1B1B19"/>
+                </a:solidFill>
+                <a:latin typeface="IBM Plex Sans"/>
+              </a:rPr>
+              <a:t>   model features, audit log, ABDM consent flow.</a:t>
+            </a:r>
+          </a:p>
+          <a:p>
+            <a:pPr>
+              <a:lnSpc>
+                <a:spcPct val="135000"/>
+              </a:lnSpc>
+            </a:pPr>
+            <a:r>
+              <a:rPr sz="1350" b="0" i="0">
+                <a:solidFill>
+                  <a:srgbClr val="1B1B19"/>
+                </a:solidFill>
+                <a:latin typeface="IBM Plex Sans"/>
+              </a:rPr>
+              <a:t/>
+            </a:r>
+          </a:p>
+          <a:p>
+            <a:pPr>
+              <a:lnSpc>
+                <a:spcPct val="135000"/>
+              </a:lnSpc>
+            </a:pPr>
+            <a:r>
+              <a:rPr sz="1350" b="0" i="0">
+                <a:solidFill>
+                  <a:srgbClr val="1B1B19"/>
+                </a:solidFill>
+                <a:latin typeface="IBM Plex Sans"/>
+              </a:rPr>
+              <a:t>•  Decision support only, not a diagnosis. The clinician</a:t>
+            </a:r>
+          </a:p>
+          <a:p>
+            <a:pPr>
+              <a:lnSpc>
+                <a:spcPct val="135000"/>
+              </a:lnSpc>
+            </a:pPr>
+            <a:r>
+              <a:rPr sz="1350" b="0" i="0">
+                <a:solidFill>
+                  <a:srgbClr val="1B1B19"/>
+                </a:solidFill>
+                <a:latin typeface="IBM Plex Sans"/>
+              </a:rPr>
+              <a:t>   decides.</a:t>
             </a:r>
           </a:p>
         </p:txBody>
       </p:sp>
       <p:cxnSp>
         <p:nvCxnSpPr>
-          <p:cNvPr id="8" name="Connector 7"/>
+          <p:cNvPr id="7" name="Connector 6"/>
           <p:cNvCxnSpPr/>
           <p:nvPr/>
         </p:nvCxnSpPr>
         <p:spPr>
           <a:xfrm>
-            <a:off x="822960" y="2304288"/>
-            <a:ext cx="10607040" cy="0"/>
+            <a:off x="6400800" y="1645920"/>
+            <a:ext cx="5029200" cy="0"/>
           </a:xfrm>
           <a:prstGeom prst="line">
             <a:avLst/>
           </a:prstGeom>
           <a:ln w="10160">
             <a:solidFill>
-              <a:srgbClr val="75726B"/>
+              <a:srgbClr val="D8D3C8"/>
             </a:solidFill>
           </a:ln>
         </p:spPr>
@@ -5308,539 +5178,206 @@
       </p:cxnSp>
       <p:sp>
         <p:nvSpPr>
+          <p:cNvPr id="8" name="TextBox 7"/>
+          <p:cNvSpPr txBox="1"/>
+          <p:nvPr/>
+        </p:nvSpPr>
+        <p:spPr>
+          <a:xfrm>
+            <a:off x="6400800" y="1783080"/>
+            <a:ext cx="5029200" cy="365760"/>
+          </a:xfrm>
+          <a:prstGeom prst="rect">
+            <a:avLst/>
+          </a:prstGeom>
+          <a:noFill/>
+        </p:spPr>
+        <p:txBody>
+          <a:bodyPr wrap="none" lIns="0" rIns="0" tIns="0" bIns="0">
+            <a:spAutoFit/>
+          </a:bodyPr>
+          <a:lstStyle/>
+          <a:p>
+            <a:pPr>
+              <a:lnSpc>
+                <a:spcPct val="135000"/>
+              </a:lnSpc>
+            </a:pPr>
+            <a:r>
+              <a:rPr sz="1400" b="0" i="0">
+                <a:solidFill>
+                  <a:srgbClr val="1B1B19"/>
+                </a:solidFill>
+                <a:latin typeface="IBM Plex Serif"/>
+              </a:rPr>
+              <a:t>Limitations we state openly</a:t>
+            </a:r>
+          </a:p>
+        </p:txBody>
+      </p:sp>
+      <p:sp>
+        <p:nvSpPr>
           <p:cNvPr id="9" name="TextBox 8"/>
           <p:cNvSpPr txBox="1"/>
           <p:nvPr/>
         </p:nvSpPr>
         <p:spPr>
           <a:xfrm>
-            <a:off x="822960" y="2377440"/>
-            <a:ext cx="2103120" cy="365760"/>
-          </a:xfrm>
-          <a:prstGeom prst="rect">
-            <a:avLst/>
-          </a:prstGeom>
-          <a:noFill/>
-        </p:spPr>
-        <p:txBody>
-          <a:bodyPr wrap="none" lIns="0" rIns="0" tIns="0" bIns="0">
-            <a:spAutoFit/>
-          </a:bodyPr>
-          <a:lstStyle/>
-          <a:p>
-            <a:pPr>
-              <a:lnSpc>
-                <a:spcPct val="130000"/>
+            <a:off x="6400800" y="2286000"/>
+            <a:ext cx="5029200" cy="2097405"/>
+          </a:xfrm>
+          <a:prstGeom prst="rect">
+            <a:avLst/>
+          </a:prstGeom>
+          <a:noFill/>
+        </p:spPr>
+        <p:txBody>
+          <a:bodyPr wrap="none" lIns="0" rIns="0" tIns="0" bIns="0">
+            <a:spAutoFit/>
+          </a:bodyPr>
+          <a:lstStyle/>
+          <a:p>
+            <a:pPr>
+              <a:lnSpc>
+                <a:spcPct val="135000"/>
               </a:lnSpc>
             </a:pPr>
             <a:r>
               <a:rPr sz="1300" b="0" i="0">
                 <a:solidFill>
-                  <a:srgbClr val="1B1B19"/>
-                </a:solidFill>
-                <a:latin typeface="IBM Plex Sans"/>
-              </a:rPr>
-              <a:t>3 months</a:t>
-            </a:r>
-          </a:p>
-        </p:txBody>
-      </p:sp>
-      <p:sp>
-        <p:nvSpPr>
-          <p:cNvPr id="10" name="TextBox 9"/>
-          <p:cNvSpPr txBox="1"/>
-          <p:nvPr/>
-        </p:nvSpPr>
-        <p:spPr>
-          <a:xfrm>
-            <a:off x="3017520" y="2377440"/>
-            <a:ext cx="8321040" cy="520700"/>
-          </a:xfrm>
-          <a:prstGeom prst="rect">
-            <a:avLst/>
-          </a:prstGeom>
-          <a:noFill/>
-        </p:spPr>
-        <p:txBody>
-          <a:bodyPr wrap="none" lIns="0" rIns="0" tIns="0" bIns="0">
-            <a:spAutoFit/>
-          </a:bodyPr>
-          <a:lstStyle/>
-          <a:p>
-            <a:pPr>
-              <a:lnSpc>
-                <a:spcPct val="130000"/>
+                  <a:srgbClr val="4A4843"/>
+                </a:solidFill>
+                <a:latin typeface="IBM Plex Sans"/>
+              </a:rPr>
+              <a:t>•  Synthetic ground truth is still a model; real data will be</a:t>
+            </a:r>
+          </a:p>
+          <a:p>
+            <a:pPr>
+              <a:lnSpc>
+                <a:spcPct val="135000"/>
               </a:lnSpc>
             </a:pPr>
             <a:r>
               <a:rPr sz="1300" b="0" i="0">
                 <a:solidFill>
-                  <a:srgbClr val="1B1B19"/>
-                </a:solidFill>
-                <a:latin typeface="IBM Plex Sans"/>
-              </a:rPr>
-              <a:t>Retrospective validation on de-identified CGM and EHR data under an ethics approval; Indian food</a:t>
-            </a:r>
-          </a:p>
-          <a:p>
-            <a:pPr>
-              <a:lnSpc>
-                <a:spcPct val="130000"/>
+                  <a:srgbClr val="4A4843"/>
+                </a:solidFill>
+                <a:latin typeface="IBM Plex Sans"/>
+              </a:rPr>
+              <a:t>   harder.</a:t>
+            </a:r>
+          </a:p>
+          <a:p>
+            <a:pPr>
+              <a:lnSpc>
+                <a:spcPct val="135000"/>
               </a:lnSpc>
             </a:pPr>
             <a:r>
               <a:rPr sz="1300" b="0" i="0">
                 <a:solidFill>
-                  <a:srgbClr val="1B1B19"/>
-                </a:solidFill>
-                <a:latin typeface="IBM Plex Sans"/>
-              </a:rPr>
-              <a:t>absorption library.</a:t>
-            </a:r>
-          </a:p>
-        </p:txBody>
-      </p:sp>
-      <p:cxnSp>
-        <p:nvCxnSpPr>
-          <p:cNvPr id="11" name="Connector 10"/>
-          <p:cNvCxnSpPr/>
-          <p:nvPr/>
-        </p:nvCxnSpPr>
-        <p:spPr>
-          <a:xfrm>
-            <a:off x="822960" y="2962656"/>
-            <a:ext cx="10607040" cy="0"/>
-          </a:xfrm>
-          <a:prstGeom prst="line">
-            <a:avLst/>
-          </a:prstGeom>
-          <a:ln w="7620">
-            <a:solidFill>
-              <a:srgbClr val="D8D3C8"/>
-            </a:solidFill>
-          </a:ln>
-        </p:spPr>
-        <p:style>
-          <a:lnRef idx="2">
-            <a:schemeClr val="accent1"/>
-          </a:lnRef>
-          <a:fillRef idx="0">
-            <a:schemeClr val="accent1"/>
-          </a:fillRef>
-          <a:effectRef idx="1">
-            <a:schemeClr val="accent1"/>
-          </a:effectRef>
-          <a:fontRef idx="minor">
-            <a:schemeClr val="tx1"/>
-          </a:fontRef>
-        </p:style>
-      </p:cxnSp>
-      <p:sp>
-        <p:nvSpPr>
-          <p:cNvPr id="12" name="TextBox 11"/>
-          <p:cNvSpPr txBox="1"/>
-          <p:nvPr/>
-        </p:nvSpPr>
-        <p:spPr>
-          <a:xfrm>
-            <a:off x="822960" y="3035808"/>
-            <a:ext cx="2103120" cy="365760"/>
-          </a:xfrm>
-          <a:prstGeom prst="rect">
-            <a:avLst/>
-          </a:prstGeom>
-          <a:noFill/>
-        </p:spPr>
-        <p:txBody>
-          <a:bodyPr wrap="none" lIns="0" rIns="0" tIns="0" bIns="0">
-            <a:spAutoFit/>
-          </a:bodyPr>
-          <a:lstStyle/>
-          <a:p>
-            <a:pPr>
-              <a:lnSpc>
-                <a:spcPct val="130000"/>
+                  <a:srgbClr val="4A4843"/>
+                </a:solidFill>
+                <a:latin typeface="IBM Plex Sans"/>
+              </a:rPr>
+              <a:t/>
+            </a:r>
+          </a:p>
+          <a:p>
+            <a:pPr>
+              <a:lnSpc>
+                <a:spcPct val="135000"/>
               </a:lnSpc>
             </a:pPr>
             <a:r>
               <a:rPr sz="1300" b="0" i="0">
                 <a:solidFill>
-                  <a:srgbClr val="1B1B19"/>
-                </a:solidFill>
-                <a:latin typeface="IBM Plex Sans"/>
-              </a:rPr>
-              <a:t>6 months</a:t>
-            </a:r>
-          </a:p>
-        </p:txBody>
-      </p:sp>
-      <p:sp>
-        <p:nvSpPr>
-          <p:cNvPr id="13" name="TextBox 12"/>
-          <p:cNvSpPr txBox="1"/>
-          <p:nvPr/>
-        </p:nvSpPr>
-        <p:spPr>
-          <a:xfrm>
-            <a:off x="3017520" y="3035808"/>
-            <a:ext cx="8321040" cy="520700"/>
-          </a:xfrm>
-          <a:prstGeom prst="rect">
-            <a:avLst/>
-          </a:prstGeom>
-          <a:noFill/>
-        </p:spPr>
-        <p:txBody>
-          <a:bodyPr wrap="none" lIns="0" rIns="0" tIns="0" bIns="0">
-            <a:spAutoFit/>
-          </a:bodyPr>
-          <a:lstStyle/>
-          <a:p>
-            <a:pPr>
-              <a:lnSpc>
-                <a:spcPct val="130000"/>
+                  <a:srgbClr val="4A4843"/>
+                </a:solidFill>
+                <a:latin typeface="IBM Plex Sans"/>
+              </a:rPr>
+              <a:t>•  Only 6 cardiovascular events in test patients.</a:t>
+            </a:r>
+          </a:p>
+          <a:p>
+            <a:pPr>
+              <a:lnSpc>
+                <a:spcPct val="135000"/>
               </a:lnSpc>
             </a:pPr>
             <a:r>
               <a:rPr sz="1300" b="0" i="0">
                 <a:solidFill>
-                  <a:srgbClr val="1B1B19"/>
-                </a:solidFill>
-                <a:latin typeface="IBM Plex Sans"/>
-              </a:rPr>
-              <a:t>Federated learning of the residual model across hospitals; the twin stays per patient, only model updates</a:t>
-            </a:r>
-          </a:p>
-          <a:p>
-            <a:pPr>
-              <a:lnSpc>
-                <a:spcPct val="130000"/>
+                  <a:srgbClr val="4A4843"/>
+                </a:solidFill>
+                <a:latin typeface="IBM Plex Sans"/>
+              </a:rPr>
+              <a:t/>
+            </a:r>
+          </a:p>
+          <a:p>
+            <a:pPr>
+              <a:lnSpc>
+                <a:spcPct val="135000"/>
               </a:lnSpc>
             </a:pPr>
             <a:r>
               <a:rPr sz="1300" b="0" i="0">
                 <a:solidFill>
-                  <a:srgbClr val="1B1B19"/>
-                </a:solidFill>
-                <a:latin typeface="IBM Plex Sans"/>
-              </a:rPr>
-              <a:t>move.</a:t>
-            </a:r>
-          </a:p>
-        </p:txBody>
-      </p:sp>
-      <p:cxnSp>
-        <p:nvCxnSpPr>
-          <p:cNvPr id="14" name="Connector 13"/>
-          <p:cNvCxnSpPr/>
-          <p:nvPr/>
-        </p:nvCxnSpPr>
-        <p:spPr>
-          <a:xfrm>
-            <a:off x="822960" y="3621024"/>
-            <a:ext cx="10607040" cy="0"/>
-          </a:xfrm>
-          <a:prstGeom prst="line">
-            <a:avLst/>
-          </a:prstGeom>
-          <a:ln w="7620">
-            <a:solidFill>
-              <a:srgbClr val="D8D3C8"/>
-            </a:solidFill>
-          </a:ln>
-        </p:spPr>
-        <p:style>
-          <a:lnRef idx="2">
-            <a:schemeClr val="accent1"/>
-          </a:lnRef>
-          <a:fillRef idx="0">
-            <a:schemeClr val="accent1"/>
-          </a:fillRef>
-          <a:effectRef idx="1">
-            <a:schemeClr val="accent1"/>
-          </a:effectRef>
-          <a:fontRef idx="minor">
-            <a:schemeClr val="tx1"/>
-          </a:fontRef>
-        </p:style>
-      </p:cxnSp>
-      <p:sp>
-        <p:nvSpPr>
-          <p:cNvPr id="15" name="TextBox 14"/>
-          <p:cNvSpPr txBox="1"/>
-          <p:nvPr/>
-        </p:nvSpPr>
-        <p:spPr>
-          <a:xfrm>
-            <a:off x="822960" y="3694176"/>
-            <a:ext cx="2103120" cy="365760"/>
-          </a:xfrm>
-          <a:prstGeom prst="rect">
-            <a:avLst/>
-          </a:prstGeom>
-          <a:noFill/>
-        </p:spPr>
-        <p:txBody>
-          <a:bodyPr wrap="none" lIns="0" rIns="0" tIns="0" bIns="0">
-            <a:spAutoFit/>
-          </a:bodyPr>
-          <a:lstStyle/>
-          <a:p>
-            <a:pPr>
-              <a:lnSpc>
-                <a:spcPct val="130000"/>
+                  <a:srgbClr val="4A4843"/>
+                </a:solidFill>
+                <a:latin typeface="IBM Plex Sans"/>
+              </a:rPr>
+              <a:t>•  Conformal coverage is approximate with serially correlated</a:t>
+            </a:r>
+          </a:p>
+          <a:p>
+            <a:pPr>
+              <a:lnSpc>
+                <a:spcPct val="135000"/>
               </a:lnSpc>
             </a:pPr>
             <a:r>
               <a:rPr sz="1300" b="0" i="0">
                 <a:solidFill>
-                  <a:srgbClr val="1B1B19"/>
-                </a:solidFill>
-                <a:latin typeface="IBM Plex Sans"/>
-              </a:rPr>
-              <a:t>9 months</a:t>
-            </a:r>
-          </a:p>
-        </p:txBody>
-      </p:sp>
-      <p:sp>
-        <p:nvSpPr>
-          <p:cNvPr id="16" name="TextBox 15"/>
-          <p:cNvSpPr txBox="1"/>
-          <p:nvPr/>
-        </p:nvSpPr>
-        <p:spPr>
-          <a:xfrm>
-            <a:off x="3017520" y="3694176"/>
-            <a:ext cx="8321040" cy="365760"/>
-          </a:xfrm>
-          <a:prstGeom prst="rect">
-            <a:avLst/>
-          </a:prstGeom>
-          <a:noFill/>
-        </p:spPr>
-        <p:txBody>
-          <a:bodyPr wrap="none" lIns="0" rIns="0" tIns="0" bIns="0">
-            <a:spAutoFit/>
-          </a:bodyPr>
-          <a:lstStyle/>
-          <a:p>
-            <a:pPr>
-              <a:lnSpc>
-                <a:spcPct val="130000"/>
+                  <a:srgbClr val="4A4843"/>
+                </a:solidFill>
+                <a:latin typeface="IBM Plex Sans"/>
+              </a:rPr>
+              <a:t>   readings, and lower below 70 mg/dL.</a:t>
+            </a:r>
+          </a:p>
+          <a:p>
+            <a:pPr>
+              <a:lnSpc>
+                <a:spcPct val="135000"/>
               </a:lnSpc>
             </a:pPr>
             <a:r>
               <a:rPr sz="1300" b="0" i="0">
                 <a:solidFill>
-                  <a:srgbClr val="1B1B19"/>
-                </a:solidFill>
-                <a:latin typeface="IBM Plex Sans"/>
-              </a:rPr>
-              <a:t>ABDM integration (health ID, consent manager, FHIR); real device APIs (Libre, Dexcom, Health Connect).</a:t>
-            </a:r>
-          </a:p>
-        </p:txBody>
-      </p:sp>
-      <p:cxnSp>
-        <p:nvCxnSpPr>
-          <p:cNvPr id="17" name="Connector 16"/>
-          <p:cNvCxnSpPr/>
-          <p:nvPr/>
-        </p:nvCxnSpPr>
-        <p:spPr>
-          <a:xfrm>
-            <a:off x="822960" y="4279392"/>
-            <a:ext cx="10607040" cy="0"/>
-          </a:xfrm>
-          <a:prstGeom prst="line">
-            <a:avLst/>
-          </a:prstGeom>
-          <a:ln w="7620">
-            <a:solidFill>
-              <a:srgbClr val="D8D3C8"/>
-            </a:solidFill>
-          </a:ln>
-        </p:spPr>
-        <p:style>
-          <a:lnRef idx="2">
-            <a:schemeClr val="accent1"/>
-          </a:lnRef>
-          <a:fillRef idx="0">
-            <a:schemeClr val="accent1"/>
-          </a:fillRef>
-          <a:effectRef idx="1">
-            <a:schemeClr val="accent1"/>
-          </a:effectRef>
-          <a:fontRef idx="minor">
-            <a:schemeClr val="tx1"/>
-          </a:fontRef>
-        </p:style>
-      </p:cxnSp>
-      <p:sp>
-        <p:nvSpPr>
-          <p:cNvPr id="18" name="TextBox 17"/>
-          <p:cNvSpPr txBox="1"/>
-          <p:nvPr/>
-        </p:nvSpPr>
-        <p:spPr>
-          <a:xfrm>
-            <a:off x="822960" y="4352544"/>
-            <a:ext cx="2103120" cy="365760"/>
-          </a:xfrm>
-          <a:prstGeom prst="rect">
-            <a:avLst/>
-          </a:prstGeom>
-          <a:noFill/>
-        </p:spPr>
-        <p:txBody>
-          <a:bodyPr wrap="none" lIns="0" rIns="0" tIns="0" bIns="0">
-            <a:spAutoFit/>
-          </a:bodyPr>
-          <a:lstStyle/>
-          <a:p>
-            <a:pPr>
-              <a:lnSpc>
-                <a:spcPct val="130000"/>
+                  <a:srgbClr val="4A4843"/>
+                </a:solidFill>
+                <a:latin typeface="IBM Plex Sans"/>
+              </a:rPr>
+              <a:t/>
+            </a:r>
+          </a:p>
+          <a:p>
+            <a:pPr>
+              <a:lnSpc>
+                <a:spcPct val="135000"/>
               </a:lnSpc>
             </a:pPr>
             <a:r>
               <a:rPr sz="1300" b="0" i="0">
                 <a:solidFill>
-                  <a:srgbClr val="1B1B19"/>
-                </a:solidFill>
-                <a:latin typeface="IBM Plex Sans"/>
-              </a:rPr>
-              <a:t>12 months</a:t>
-            </a:r>
-          </a:p>
-        </p:txBody>
-      </p:sp>
-      <p:sp>
-        <p:nvSpPr>
-          <p:cNvPr id="19" name="TextBox 18"/>
-          <p:cNvSpPr txBox="1"/>
-          <p:nvPr/>
-        </p:nvSpPr>
-        <p:spPr>
-          <a:xfrm>
-            <a:off x="3017520" y="4352544"/>
-            <a:ext cx="8321040" cy="365760"/>
-          </a:xfrm>
-          <a:prstGeom prst="rect">
-            <a:avLst/>
-          </a:prstGeom>
-          <a:noFill/>
-        </p:spPr>
-        <p:txBody>
-          <a:bodyPr wrap="none" lIns="0" rIns="0" tIns="0" bIns="0">
-            <a:spAutoFit/>
-          </a:bodyPr>
-          <a:lstStyle/>
-          <a:p>
-            <a:pPr>
-              <a:lnSpc>
-                <a:spcPct val="130000"/>
-              </a:lnSpc>
-            </a:pPr>
-            <a:r>
-              <a:rPr sz="1300" b="0" i="0">
-                <a:solidFill>
-                  <a:srgbClr val="1B1B19"/>
-                </a:solidFill>
-                <a:latin typeface="IBM Plex Sans"/>
-              </a:rPr>
-              <a:t>Prospective pilot in a diabetes clinic with alert burden and time in range as outcomes.</a:t>
-            </a:r>
-          </a:p>
-        </p:txBody>
-      </p:sp>
-      <p:cxnSp>
-        <p:nvCxnSpPr>
-          <p:cNvPr id="20" name="Connector 19"/>
-          <p:cNvCxnSpPr/>
-          <p:nvPr/>
-        </p:nvCxnSpPr>
-        <p:spPr>
-          <a:xfrm>
-            <a:off x="822960" y="4937759"/>
-            <a:ext cx="10607040" cy="0"/>
-          </a:xfrm>
-          <a:prstGeom prst="line">
-            <a:avLst/>
-          </a:prstGeom>
-          <a:ln w="7620">
-            <a:solidFill>
-              <a:srgbClr val="D8D3C8"/>
-            </a:solidFill>
-          </a:ln>
-        </p:spPr>
-        <p:style>
-          <a:lnRef idx="2">
-            <a:schemeClr val="accent1"/>
-          </a:lnRef>
-          <a:fillRef idx="0">
-            <a:schemeClr val="accent1"/>
-          </a:fillRef>
-          <a:effectRef idx="1">
-            <a:schemeClr val="accent1"/>
-          </a:effectRef>
-          <a:fontRef idx="minor">
-            <a:schemeClr val="tx1"/>
-          </a:fontRef>
-        </p:style>
-      </p:cxnSp>
-      <p:sp>
-        <p:nvSpPr>
-          <p:cNvPr id="21" name="TextBox 20"/>
-          <p:cNvSpPr txBox="1"/>
-          <p:nvPr/>
-        </p:nvSpPr>
-        <p:spPr>
-          <a:xfrm>
-            <a:off x="822960" y="5486400"/>
-            <a:ext cx="10515600" cy="571500"/>
-          </a:xfrm>
-          <a:prstGeom prst="rect">
-            <a:avLst/>
-          </a:prstGeom>
-          <a:noFill/>
-        </p:spPr>
-        <p:txBody>
-          <a:bodyPr wrap="none" lIns="0" rIns="0" tIns="0" bIns="0">
-            <a:spAutoFit/>
-          </a:bodyPr>
-          <a:lstStyle/>
-          <a:p>
-            <a:pPr>
-              <a:lnSpc>
-                <a:spcPct val="135000"/>
-              </a:lnSpc>
-            </a:pPr>
-            <a:r>
-              <a:rPr sz="1400" b="0" i="1">
-                <a:solidFill>
-                  <a:srgbClr val="1B1B19"/>
-                </a:solidFill>
-                <a:latin typeface="IBM Plex Serif"/>
-              </a:rPr>
-              <a:t>Impact: fewer hours above range, earlier review of cardiac drift, and conversations about change grounded in the patient's</a:t>
-            </a:r>
-          </a:p>
-          <a:p>
-            <a:pPr>
-              <a:lnSpc>
-                <a:spcPct val="135000"/>
-              </a:lnSpc>
-            </a:pPr>
-            <a:r>
-              <a:rPr sz="1400" b="0" i="1">
-                <a:solidFill>
-                  <a:srgbClr val="1B1B19"/>
-                </a:solidFill>
-                <a:latin typeface="IBM Plex Serif"/>
-              </a:rPr>
-              <a:t>own physiology.</a:t>
+                  <a:srgbClr val="4A4843"/>
+                </a:solidFill>
+                <a:latin typeface="IBM Plex Sans"/>
+              </a:rPr>
+              <a:t>•  Unlogged meals remain the main source of missed spikes.</a:t>
             </a:r>
           </a:p>
         </p:txBody>
@@ -5901,11 +5438,11 @@
             <a:r>
               <a:rPr sz="1000" b="0" i="0">
                 <a:solidFill>
-                  <a:srgbClr val="75726B"/>
-                </a:solidFill>
-                <a:latin typeface="IBM Plex Sans"/>
-              </a:rPr>
-              <a:t>CONTACT</a:t>
+                  <a:srgbClr val="6A675F"/>
+                </a:solidFill>
+                <a:latin typeface="IBM Plex Sans"/>
+              </a:rPr>
+              <a:t>NEXT</a:t>
             </a:r>
           </a:p>
         </p:txBody>
@@ -5944,7 +5481,7 @@
                 </a:solidFill>
                 <a:latin typeface="IBM Plex Serif"/>
               </a:rPr>
-              <a:t>Team</a:t>
+              <a:t>Impact and roadmap</a:t>
             </a:r>
           </a:p>
         </p:txBody>
@@ -6014,7 +5551,7 @@
             <a:r>
               <a:rPr sz="900" b="0" i="0">
                 <a:solidFill>
-                  <a:srgbClr val="75726B"/>
+                  <a:srgbClr val="6A675F"/>
                 </a:solidFill>
                 <a:latin typeface="IBM Plex Sans"/>
               </a:rPr>
@@ -6031,8 +5568,8 @@
         </p:nvSpPr>
         <p:spPr>
           <a:xfrm>
-            <a:off x="822960" y="1810512"/>
-            <a:ext cx="3200400" cy="365760"/>
+            <a:off x="822960" y="1719072"/>
+            <a:ext cx="2103120" cy="365760"/>
           </a:xfrm>
           <a:prstGeom prst="rect">
             <a:avLst/>
@@ -6051,13 +5588,13 @@
               </a:lnSpc>
             </a:pPr>
             <a:r>
-              <a:rPr sz="1250" b="0" i="0">
-                <a:solidFill>
-                  <a:srgbClr val="75726B"/>
-                </a:solidFill>
-                <a:latin typeface="IBM Plex Sans"/>
-              </a:rPr>
-              <a:t>Name</a:t>
+              <a:rPr sz="1150" b="0" i="0">
+                <a:solidFill>
+                  <a:srgbClr val="6A675F"/>
+                </a:solidFill>
+                <a:latin typeface="IBM Plex Sans"/>
+              </a:rPr>
+              <a:t>Now</a:t>
             </a:r>
           </a:p>
         </p:txBody>
@@ -6070,8 +5607,8 @@
         </p:nvSpPr>
         <p:spPr>
           <a:xfrm>
-            <a:off x="4114800" y="1810512"/>
-            <a:ext cx="3200400" cy="365760"/>
+            <a:off x="3017520" y="1719072"/>
+            <a:ext cx="8321040" cy="365760"/>
           </a:xfrm>
           <a:prstGeom prst="rect">
             <a:avLst/>
@@ -6090,65 +5627,26 @@
               </a:lnSpc>
             </a:pPr>
             <a:r>
-              <a:rPr sz="1250" b="0" i="0">
-                <a:solidFill>
-                  <a:srgbClr val="75726B"/>
-                </a:solidFill>
-                <a:latin typeface="IBM Plex Sans"/>
-              </a:rPr>
-              <a:t>Role</a:t>
-            </a:r>
-          </a:p>
-        </p:txBody>
-      </p:sp>
-      <p:sp>
-        <p:nvSpPr>
-          <p:cNvPr id="8" name="TextBox 7"/>
-          <p:cNvSpPr txBox="1"/>
-          <p:nvPr/>
-        </p:nvSpPr>
-        <p:spPr>
-          <a:xfrm>
-            <a:off x="7406640" y="1810512"/>
-            <a:ext cx="3931920" cy="365760"/>
-          </a:xfrm>
-          <a:prstGeom prst="rect">
-            <a:avLst/>
-          </a:prstGeom>
-          <a:noFill/>
-        </p:spPr>
-        <p:txBody>
-          <a:bodyPr wrap="none" lIns="0" rIns="0" tIns="0" bIns="0">
-            <a:spAutoFit/>
-          </a:bodyPr>
-          <a:lstStyle/>
-          <a:p>
-            <a:pPr>
-              <a:lnSpc>
-                <a:spcPct val="130000"/>
-              </a:lnSpc>
-            </a:pPr>
-            <a:r>
-              <a:rPr sz="1250" b="0" i="0">
-                <a:solidFill>
-                  <a:srgbClr val="75726B"/>
-                </a:solidFill>
-                <a:latin typeface="IBM Plex Sans"/>
-              </a:rPr>
-              <a:t>Email</a:t>
+              <a:rPr sz="1150" b="0" i="0">
+                <a:solidFill>
+                  <a:srgbClr val="6A675F"/>
+                </a:solidFill>
+                <a:latin typeface="IBM Plex Sans"/>
+              </a:rPr>
+              <a:t>Working prototype: data, twin, models, API, dashboard, tests, docs. Reproducible from one seed.</a:t>
             </a:r>
           </a:p>
         </p:txBody>
       </p:sp>
       <p:cxnSp>
         <p:nvCxnSpPr>
-          <p:cNvPr id="9" name="Connector 8"/>
+          <p:cNvPr id="8" name="Connector 7"/>
           <p:cNvCxnSpPr/>
           <p:nvPr/>
         </p:nvCxnSpPr>
         <p:spPr>
           <a:xfrm>
-            <a:off x="822960" y="2286000"/>
+            <a:off x="822960" y="2304288"/>
             <a:ext cx="10607040" cy="0"/>
           </a:xfrm>
           <a:prstGeom prst="line">
@@ -6156,7 +5654,7 @@
           </a:prstGeom>
           <a:ln w="10160">
             <a:solidFill>
-              <a:srgbClr val="75726B"/>
+              <a:srgbClr val="6A675F"/>
             </a:solidFill>
           </a:ln>
         </p:spPr>
@@ -6177,14 +5675,53 @@
       </p:cxnSp>
       <p:sp>
         <p:nvSpPr>
+          <p:cNvPr id="9" name="TextBox 8"/>
+          <p:cNvSpPr txBox="1"/>
+          <p:nvPr/>
+        </p:nvSpPr>
+        <p:spPr>
+          <a:xfrm>
+            <a:off x="822960" y="2377440"/>
+            <a:ext cx="2103120" cy="365760"/>
+          </a:xfrm>
+          <a:prstGeom prst="rect">
+            <a:avLst/>
+          </a:prstGeom>
+          <a:noFill/>
+        </p:spPr>
+        <p:txBody>
+          <a:bodyPr wrap="none" lIns="0" rIns="0" tIns="0" bIns="0">
+            <a:spAutoFit/>
+          </a:bodyPr>
+          <a:lstStyle/>
+          <a:p>
+            <a:pPr>
+              <a:lnSpc>
+                <a:spcPct val="130000"/>
+              </a:lnSpc>
+            </a:pPr>
+            <a:r>
+              <a:rPr sz="1300" b="0" i="0">
+                <a:solidFill>
+                  <a:srgbClr val="1B1B19"/>
+                </a:solidFill>
+                <a:latin typeface="IBM Plex Sans"/>
+              </a:rPr>
+              <a:t>3 months</a:t>
+            </a:r>
+          </a:p>
+        </p:txBody>
+      </p:sp>
+      <p:sp>
+        <p:nvSpPr>
           <p:cNvPr id="10" name="TextBox 9"/>
           <p:cNvSpPr txBox="1"/>
           <p:nvPr/>
         </p:nvSpPr>
         <p:spPr>
           <a:xfrm>
-            <a:off x="822960" y="2359152"/>
-            <a:ext cx="3200400" cy="365760"/>
+            <a:off x="3017520" y="2377440"/>
+            <a:ext cx="8321040" cy="520700"/>
           </a:xfrm>
           <a:prstGeom prst="rect">
             <a:avLst/>
@@ -6203,38 +5740,15 @@
               </a:lnSpc>
             </a:pPr>
             <a:r>
-              <a:rPr sz="1400" b="0" i="0">
-                <a:solidFill>
-                  <a:srgbClr val="1B1B19"/>
-                </a:solidFill>
-                <a:latin typeface="IBM Plex Sans"/>
-              </a:rPr>
-              <a:t>&lt;Member 1&gt;</a:t>
-            </a:r>
-          </a:p>
-        </p:txBody>
-      </p:sp>
-      <p:sp>
-        <p:nvSpPr>
-          <p:cNvPr id="11" name="TextBox 10"/>
-          <p:cNvSpPr txBox="1"/>
-          <p:nvPr/>
-        </p:nvSpPr>
-        <p:spPr>
-          <a:xfrm>
-            <a:off x="4114800" y="2359152"/>
-            <a:ext cx="3200400" cy="365760"/>
-          </a:xfrm>
-          <a:prstGeom prst="rect">
-            <a:avLst/>
-          </a:prstGeom>
-          <a:noFill/>
-        </p:spPr>
-        <p:txBody>
-          <a:bodyPr wrap="none" lIns="0" rIns="0" tIns="0" bIns="0">
-            <a:spAutoFit/>
-          </a:bodyPr>
-          <a:lstStyle/>
+              <a:rPr sz="1300" b="0" i="0">
+                <a:solidFill>
+                  <a:srgbClr val="1B1B19"/>
+                </a:solidFill>
+                <a:latin typeface="IBM Plex Sans"/>
+              </a:rPr>
+              <a:t>Retrospective validation on de-identified CGM and EHR data under an ethics approval; Indian food</a:t>
+            </a:r>
+          </a:p>
           <a:p>
             <a:pPr>
               <a:lnSpc>
@@ -6242,65 +5756,26 @@
               </a:lnSpc>
             </a:pPr>
             <a:r>
-              <a:rPr sz="1400" b="0" i="0">
-                <a:solidFill>
-                  <a:srgbClr val="1B1B19"/>
-                </a:solidFill>
-                <a:latin typeface="IBM Plex Sans"/>
-              </a:rPr>
-              <a:t>&lt;Role&gt;</a:t>
-            </a:r>
-          </a:p>
-        </p:txBody>
-      </p:sp>
-      <p:sp>
-        <p:nvSpPr>
-          <p:cNvPr id="12" name="TextBox 11"/>
-          <p:cNvSpPr txBox="1"/>
-          <p:nvPr/>
-        </p:nvSpPr>
-        <p:spPr>
-          <a:xfrm>
-            <a:off x="7406640" y="2359152"/>
-            <a:ext cx="3931920" cy="365760"/>
-          </a:xfrm>
-          <a:prstGeom prst="rect">
-            <a:avLst/>
-          </a:prstGeom>
-          <a:noFill/>
-        </p:spPr>
-        <p:txBody>
-          <a:bodyPr wrap="none" lIns="0" rIns="0" tIns="0" bIns="0">
-            <a:spAutoFit/>
-          </a:bodyPr>
-          <a:lstStyle/>
-          <a:p>
-            <a:pPr>
-              <a:lnSpc>
-                <a:spcPct val="130000"/>
-              </a:lnSpc>
-            </a:pPr>
-            <a:r>
-              <a:rPr sz="1400" b="0" i="0">
-                <a:solidFill>
-                  <a:srgbClr val="1B1B19"/>
-                </a:solidFill>
-                <a:latin typeface="IBM Plex Sans"/>
-              </a:rPr>
-              <a:t>&lt;email&gt;</a:t>
+              <a:rPr sz="1300" b="0" i="0">
+                <a:solidFill>
+                  <a:srgbClr val="1B1B19"/>
+                </a:solidFill>
+                <a:latin typeface="IBM Plex Sans"/>
+              </a:rPr>
+              <a:t>absorption library.</a:t>
             </a:r>
           </a:p>
         </p:txBody>
       </p:sp>
       <p:cxnSp>
         <p:nvCxnSpPr>
-          <p:cNvPr id="13" name="Connector 12"/>
+          <p:cNvPr id="11" name="Connector 10"/>
           <p:cNvCxnSpPr/>
           <p:nvPr/>
         </p:nvCxnSpPr>
         <p:spPr>
           <a:xfrm>
-            <a:off x="822960" y="2834640"/>
+            <a:off x="822960" y="2962656"/>
             <a:ext cx="10607040" cy="0"/>
           </a:xfrm>
           <a:prstGeom prst="line">
@@ -6329,14 +5804,14 @@
       </p:cxnSp>
       <p:sp>
         <p:nvSpPr>
-          <p:cNvPr id="14" name="TextBox 13"/>
-          <p:cNvSpPr txBox="1"/>
-          <p:nvPr/>
-        </p:nvSpPr>
-        <p:spPr>
-          <a:xfrm>
-            <a:off x="822960" y="2907792"/>
-            <a:ext cx="3200400" cy="365760"/>
+          <p:cNvPr id="12" name="TextBox 11"/>
+          <p:cNvSpPr txBox="1"/>
+          <p:nvPr/>
+        </p:nvSpPr>
+        <p:spPr>
+          <a:xfrm>
+            <a:off x="822960" y="3035808"/>
+            <a:ext cx="2103120" cy="365760"/>
           </a:xfrm>
           <a:prstGeom prst="rect">
             <a:avLst/>
@@ -6355,27 +5830,27 @@
               </a:lnSpc>
             </a:pPr>
             <a:r>
-              <a:rPr sz="1400" b="0" i="0">
-                <a:solidFill>
-                  <a:srgbClr val="1B1B19"/>
-                </a:solidFill>
-                <a:latin typeface="IBM Plex Sans"/>
-              </a:rPr>
-              <a:t>&lt;Member 2&gt;</a:t>
-            </a:r>
-          </a:p>
-        </p:txBody>
-      </p:sp>
-      <p:sp>
-        <p:nvSpPr>
-          <p:cNvPr id="15" name="TextBox 14"/>
-          <p:cNvSpPr txBox="1"/>
-          <p:nvPr/>
-        </p:nvSpPr>
-        <p:spPr>
-          <a:xfrm>
-            <a:off x="4114800" y="2907792"/>
-            <a:ext cx="3200400" cy="365760"/>
+              <a:rPr sz="1300" b="0" i="0">
+                <a:solidFill>
+                  <a:srgbClr val="1B1B19"/>
+                </a:solidFill>
+                <a:latin typeface="IBM Plex Sans"/>
+              </a:rPr>
+              <a:t>6 months</a:t>
+            </a:r>
+          </a:p>
+        </p:txBody>
+      </p:sp>
+      <p:sp>
+        <p:nvSpPr>
+          <p:cNvPr id="13" name="TextBox 12"/>
+          <p:cNvSpPr txBox="1"/>
+          <p:nvPr/>
+        </p:nvSpPr>
+        <p:spPr>
+          <a:xfrm>
+            <a:off x="3017520" y="3035808"/>
+            <a:ext cx="8321040" cy="520700"/>
           </a:xfrm>
           <a:prstGeom prst="rect">
             <a:avLst/>
@@ -6394,38 +5869,15 @@
               </a:lnSpc>
             </a:pPr>
             <a:r>
-              <a:rPr sz="1400" b="0" i="0">
-                <a:solidFill>
-                  <a:srgbClr val="1B1B19"/>
-                </a:solidFill>
-                <a:latin typeface="IBM Plex Sans"/>
-              </a:rPr>
-              <a:t>&lt;Role&gt;</a:t>
-            </a:r>
-          </a:p>
-        </p:txBody>
-      </p:sp>
-      <p:sp>
-        <p:nvSpPr>
-          <p:cNvPr id="16" name="TextBox 15"/>
-          <p:cNvSpPr txBox="1"/>
-          <p:nvPr/>
-        </p:nvSpPr>
-        <p:spPr>
-          <a:xfrm>
-            <a:off x="7406640" y="2907792"/>
-            <a:ext cx="3931920" cy="365760"/>
-          </a:xfrm>
-          <a:prstGeom prst="rect">
-            <a:avLst/>
-          </a:prstGeom>
-          <a:noFill/>
-        </p:spPr>
-        <p:txBody>
-          <a:bodyPr wrap="none" lIns="0" rIns="0" tIns="0" bIns="0">
-            <a:spAutoFit/>
-          </a:bodyPr>
-          <a:lstStyle/>
+              <a:rPr sz="1300" b="0" i="0">
+                <a:solidFill>
+                  <a:srgbClr val="1B1B19"/>
+                </a:solidFill>
+                <a:latin typeface="IBM Plex Sans"/>
+              </a:rPr>
+              <a:t>Federated learning of the residual model across hospitals; the twin stays per patient, only model updates</a:t>
+            </a:r>
+          </a:p>
           <a:p>
             <a:pPr>
               <a:lnSpc>
@@ -6433,26 +5885,26 @@
               </a:lnSpc>
             </a:pPr>
             <a:r>
-              <a:rPr sz="1400" b="0" i="0">
-                <a:solidFill>
-                  <a:srgbClr val="1B1B19"/>
-                </a:solidFill>
-                <a:latin typeface="IBM Plex Sans"/>
-              </a:rPr>
-              <a:t>&lt;email&gt;</a:t>
+              <a:rPr sz="1300" b="0" i="0">
+                <a:solidFill>
+                  <a:srgbClr val="1B1B19"/>
+                </a:solidFill>
+                <a:latin typeface="IBM Plex Sans"/>
+              </a:rPr>
+              <a:t>move.</a:t>
             </a:r>
           </a:p>
         </p:txBody>
       </p:sp>
       <p:cxnSp>
         <p:nvCxnSpPr>
-          <p:cNvPr id="17" name="Connector 16"/>
+          <p:cNvPr id="14" name="Connector 13"/>
           <p:cNvCxnSpPr/>
           <p:nvPr/>
         </p:nvCxnSpPr>
         <p:spPr>
           <a:xfrm>
-            <a:off x="822960" y="3383280"/>
+            <a:off x="822960" y="3621024"/>
             <a:ext cx="10607040" cy="0"/>
           </a:xfrm>
           <a:prstGeom prst="line">
@@ -6481,14 +5933,14 @@
       </p:cxnSp>
       <p:sp>
         <p:nvSpPr>
-          <p:cNvPr id="18" name="TextBox 17"/>
-          <p:cNvSpPr txBox="1"/>
-          <p:nvPr/>
-        </p:nvSpPr>
-        <p:spPr>
-          <a:xfrm>
-            <a:off x="822960" y="3456432"/>
-            <a:ext cx="3200400" cy="365760"/>
+          <p:cNvPr id="15" name="TextBox 14"/>
+          <p:cNvSpPr txBox="1"/>
+          <p:nvPr/>
+        </p:nvSpPr>
+        <p:spPr>
+          <a:xfrm>
+            <a:off x="822960" y="3694176"/>
+            <a:ext cx="2103120" cy="365760"/>
           </a:xfrm>
           <a:prstGeom prst="rect">
             <a:avLst/>
@@ -6507,27 +5959,27 @@
               </a:lnSpc>
             </a:pPr>
             <a:r>
-              <a:rPr sz="1400" b="0" i="0">
-                <a:solidFill>
-                  <a:srgbClr val="1B1B19"/>
-                </a:solidFill>
-                <a:latin typeface="IBM Plex Sans"/>
-              </a:rPr>
-              <a:t>&lt;Member 3&gt;</a:t>
-            </a:r>
-          </a:p>
-        </p:txBody>
-      </p:sp>
-      <p:sp>
-        <p:nvSpPr>
-          <p:cNvPr id="19" name="TextBox 18"/>
-          <p:cNvSpPr txBox="1"/>
-          <p:nvPr/>
-        </p:nvSpPr>
-        <p:spPr>
-          <a:xfrm>
-            <a:off x="4114800" y="3456432"/>
-            <a:ext cx="3200400" cy="365760"/>
+              <a:rPr sz="1300" b="0" i="0">
+                <a:solidFill>
+                  <a:srgbClr val="1B1B19"/>
+                </a:solidFill>
+                <a:latin typeface="IBM Plex Sans"/>
+              </a:rPr>
+              <a:t>9 months</a:t>
+            </a:r>
+          </a:p>
+        </p:txBody>
+      </p:sp>
+      <p:sp>
+        <p:nvSpPr>
+          <p:cNvPr id="16" name="TextBox 15"/>
+          <p:cNvSpPr txBox="1"/>
+          <p:nvPr/>
+        </p:nvSpPr>
+        <p:spPr>
+          <a:xfrm>
+            <a:off x="3017520" y="3694176"/>
+            <a:ext cx="8321040" cy="365760"/>
           </a:xfrm>
           <a:prstGeom prst="rect">
             <a:avLst/>
@@ -6546,65 +5998,26 @@
               </a:lnSpc>
             </a:pPr>
             <a:r>
-              <a:rPr sz="1400" b="0" i="0">
-                <a:solidFill>
-                  <a:srgbClr val="1B1B19"/>
-                </a:solidFill>
-                <a:latin typeface="IBM Plex Sans"/>
-              </a:rPr>
-              <a:t>&lt;Role&gt;</a:t>
-            </a:r>
-          </a:p>
-        </p:txBody>
-      </p:sp>
-      <p:sp>
-        <p:nvSpPr>
-          <p:cNvPr id="20" name="TextBox 19"/>
-          <p:cNvSpPr txBox="1"/>
-          <p:nvPr/>
-        </p:nvSpPr>
-        <p:spPr>
-          <a:xfrm>
-            <a:off x="7406640" y="3456432"/>
-            <a:ext cx="3931920" cy="365760"/>
-          </a:xfrm>
-          <a:prstGeom prst="rect">
-            <a:avLst/>
-          </a:prstGeom>
-          <a:noFill/>
-        </p:spPr>
-        <p:txBody>
-          <a:bodyPr wrap="none" lIns="0" rIns="0" tIns="0" bIns="0">
-            <a:spAutoFit/>
-          </a:bodyPr>
-          <a:lstStyle/>
-          <a:p>
-            <a:pPr>
-              <a:lnSpc>
-                <a:spcPct val="130000"/>
-              </a:lnSpc>
-            </a:pPr>
-            <a:r>
-              <a:rPr sz="1400" b="0" i="0">
-                <a:solidFill>
-                  <a:srgbClr val="1B1B19"/>
-                </a:solidFill>
-                <a:latin typeface="IBM Plex Sans"/>
-              </a:rPr>
-              <a:t>&lt;email&gt;</a:t>
+              <a:rPr sz="1300" b="0" i="0">
+                <a:solidFill>
+                  <a:srgbClr val="1B1B19"/>
+                </a:solidFill>
+                <a:latin typeface="IBM Plex Sans"/>
+              </a:rPr>
+              <a:t>ABDM integration (health ID, consent manager, FHIR); real device APIs (Libre, Dexcom, Health Connect).</a:t>
             </a:r>
           </a:p>
         </p:txBody>
       </p:sp>
       <p:cxnSp>
         <p:nvCxnSpPr>
-          <p:cNvPr id="21" name="Connector 20"/>
+          <p:cNvPr id="17" name="Connector 16"/>
           <p:cNvCxnSpPr/>
           <p:nvPr/>
         </p:nvCxnSpPr>
         <p:spPr>
           <a:xfrm>
-            <a:off x="822960" y="3931920"/>
+            <a:off x="822960" y="4279392"/>
             <a:ext cx="10607040" cy="0"/>
           </a:xfrm>
           <a:prstGeom prst="line">
@@ -6633,14 +6046,14 @@
       </p:cxnSp>
       <p:sp>
         <p:nvSpPr>
-          <p:cNvPr id="22" name="TextBox 21"/>
-          <p:cNvSpPr txBox="1"/>
-          <p:nvPr/>
-        </p:nvSpPr>
-        <p:spPr>
-          <a:xfrm>
-            <a:off x="822960" y="4005072"/>
-            <a:ext cx="3200400" cy="365760"/>
+          <p:cNvPr id="18" name="TextBox 17"/>
+          <p:cNvSpPr txBox="1"/>
+          <p:nvPr/>
+        </p:nvSpPr>
+        <p:spPr>
+          <a:xfrm>
+            <a:off x="822960" y="4352544"/>
+            <a:ext cx="2103120" cy="365760"/>
           </a:xfrm>
           <a:prstGeom prst="rect">
             <a:avLst/>
@@ -6659,27 +6072,27 @@
               </a:lnSpc>
             </a:pPr>
             <a:r>
-              <a:rPr sz="1400" b="0" i="0">
-                <a:solidFill>
-                  <a:srgbClr val="1B1B19"/>
-                </a:solidFill>
-                <a:latin typeface="IBM Plex Sans"/>
-              </a:rPr>
-              <a:t>&lt;Member 4&gt;</a:t>
-            </a:r>
-          </a:p>
-        </p:txBody>
-      </p:sp>
-      <p:sp>
-        <p:nvSpPr>
-          <p:cNvPr id="23" name="TextBox 22"/>
-          <p:cNvSpPr txBox="1"/>
-          <p:nvPr/>
-        </p:nvSpPr>
-        <p:spPr>
-          <a:xfrm>
-            <a:off x="4114800" y="4005072"/>
-            <a:ext cx="3200400" cy="365760"/>
+              <a:rPr sz="1300" b="0" i="0">
+                <a:solidFill>
+                  <a:srgbClr val="1B1B19"/>
+                </a:solidFill>
+                <a:latin typeface="IBM Plex Sans"/>
+              </a:rPr>
+              <a:t>12 months</a:t>
+            </a:r>
+          </a:p>
+        </p:txBody>
+      </p:sp>
+      <p:sp>
+        <p:nvSpPr>
+          <p:cNvPr id="19" name="TextBox 18"/>
+          <p:cNvSpPr txBox="1"/>
+          <p:nvPr/>
+        </p:nvSpPr>
+        <p:spPr>
+          <a:xfrm>
+            <a:off x="3017520" y="4352544"/>
+            <a:ext cx="8321040" cy="365760"/>
           </a:xfrm>
           <a:prstGeom prst="rect">
             <a:avLst/>
@@ -6698,65 +6111,26 @@
               </a:lnSpc>
             </a:pPr>
             <a:r>
-              <a:rPr sz="1400" b="0" i="0">
-                <a:solidFill>
-                  <a:srgbClr val="1B1B19"/>
-                </a:solidFill>
-                <a:latin typeface="IBM Plex Sans"/>
-              </a:rPr>
-              <a:t>&lt;Role&gt;</a:t>
-            </a:r>
-          </a:p>
-        </p:txBody>
-      </p:sp>
-      <p:sp>
-        <p:nvSpPr>
-          <p:cNvPr id="24" name="TextBox 23"/>
-          <p:cNvSpPr txBox="1"/>
-          <p:nvPr/>
-        </p:nvSpPr>
-        <p:spPr>
-          <a:xfrm>
-            <a:off x="7406640" y="4005072"/>
-            <a:ext cx="3931920" cy="365760"/>
-          </a:xfrm>
-          <a:prstGeom prst="rect">
-            <a:avLst/>
-          </a:prstGeom>
-          <a:noFill/>
-        </p:spPr>
-        <p:txBody>
-          <a:bodyPr wrap="none" lIns="0" rIns="0" tIns="0" bIns="0">
-            <a:spAutoFit/>
-          </a:bodyPr>
-          <a:lstStyle/>
-          <a:p>
-            <a:pPr>
-              <a:lnSpc>
-                <a:spcPct val="130000"/>
-              </a:lnSpc>
-            </a:pPr>
-            <a:r>
-              <a:rPr sz="1400" b="0" i="0">
-                <a:solidFill>
-                  <a:srgbClr val="1B1B19"/>
-                </a:solidFill>
-                <a:latin typeface="IBM Plex Sans"/>
-              </a:rPr>
-              <a:t>&lt;email&gt;</a:t>
+              <a:rPr sz="1300" b="0" i="0">
+                <a:solidFill>
+                  <a:srgbClr val="1B1B19"/>
+                </a:solidFill>
+                <a:latin typeface="IBM Plex Sans"/>
+              </a:rPr>
+              <a:t>Prospective pilot in a diabetes clinic with alert burden and time in range as outcomes.</a:t>
             </a:r>
           </a:p>
         </p:txBody>
       </p:sp>
       <p:cxnSp>
         <p:nvCxnSpPr>
-          <p:cNvPr id="25" name="Connector 24"/>
+          <p:cNvPr id="20" name="Connector 19"/>
           <p:cNvCxnSpPr/>
           <p:nvPr/>
         </p:nvCxnSpPr>
         <p:spPr>
           <a:xfrm>
-            <a:off x="822960" y="4480559"/>
+            <a:off x="822960" y="4937759"/>
             <a:ext cx="10607040" cy="0"/>
           </a:xfrm>
           <a:prstGeom prst="line">
@@ -6785,13 +6159,68 @@
       </p:cxnSp>
       <p:sp>
         <p:nvSpPr>
-          <p:cNvPr id="26" name="TextBox 25"/>
-          <p:cNvSpPr txBox="1"/>
-          <p:nvPr/>
-        </p:nvSpPr>
-        <p:spPr>
-          <a:xfrm>
-            <a:off x="822960" y="4937760"/>
+          <p:cNvPr id="21" name="TextBox 20"/>
+          <p:cNvSpPr txBox="1"/>
+          <p:nvPr/>
+        </p:nvSpPr>
+        <p:spPr>
+          <a:xfrm>
+            <a:off x="822960" y="5349240"/>
+            <a:ext cx="10515600" cy="571500"/>
+          </a:xfrm>
+          <a:prstGeom prst="rect">
+            <a:avLst/>
+          </a:prstGeom>
+          <a:noFill/>
+        </p:spPr>
+        <p:txBody>
+          <a:bodyPr wrap="none" lIns="0" rIns="0" tIns="0" bIns="0">
+            <a:spAutoFit/>
+          </a:bodyPr>
+          <a:lstStyle/>
+          <a:p>
+            <a:pPr>
+              <a:lnSpc>
+                <a:spcPct val="135000"/>
+              </a:lnSpc>
+            </a:pPr>
+            <a:r>
+              <a:rPr sz="1400" b="0" i="1">
+                <a:solidFill>
+                  <a:srgbClr val="1B1B19"/>
+                </a:solidFill>
+                <a:latin typeface="IBM Plex Serif"/>
+              </a:rPr>
+              <a:t>Impact: fewer hours above range, earlier review of cardiac drift, and conversations about change grounded in the patient's</a:t>
+            </a:r>
+          </a:p>
+          <a:p>
+            <a:pPr>
+              <a:lnSpc>
+                <a:spcPct val="135000"/>
+              </a:lnSpc>
+            </a:pPr>
+            <a:r>
+              <a:rPr sz="1400" b="0" i="1">
+                <a:solidFill>
+                  <a:srgbClr val="1B1B19"/>
+                </a:solidFill>
+                <a:latin typeface="IBM Plex Serif"/>
+              </a:rPr>
+              <a:t>own physiology.</a:t>
+            </a:r>
+          </a:p>
+        </p:txBody>
+      </p:sp>
+      <p:sp>
+        <p:nvSpPr>
+          <p:cNvPr id="22" name="TextBox 21"/>
+          <p:cNvSpPr txBox="1"/>
+          <p:nvPr/>
+        </p:nvSpPr>
+        <p:spPr>
+          <a:xfrm>
+            <a:off x="822960" y="5989320"/>
             <a:ext cx="10515600" cy="365760"/>
           </a:xfrm>
           <a:prstGeom prst="rect">
@@ -6811,52 +6240,13 @@
               </a:lnSpc>
             </a:pPr>
             <a:r>
-              <a:rPr sz="1400" b="0" i="0">
+              <a:rPr sz="1300" b="0" i="0">
                 <a:solidFill>
                   <a:srgbClr val="4A4843"/>
                 </a:solidFill>
                 <a:latin typeface="IBM Plex Sans"/>
               </a:rPr>
-              <a:t>&lt;CollegeName&gt; / &lt;Incubator&gt;.  Code: &lt;public repository URL&gt;.  Demo video: &lt;unlisted YouTube URL&gt;.</a:t>
-            </a:r>
-          </a:p>
-        </p:txBody>
-      </p:sp>
-      <p:sp>
-        <p:nvSpPr>
-          <p:cNvPr id="27" name="TextBox 26"/>
-          <p:cNvSpPr txBox="1"/>
-          <p:nvPr/>
-        </p:nvSpPr>
-        <p:spPr>
-          <a:xfrm>
-            <a:off x="822960" y="5760720"/>
-            <a:ext cx="10515600" cy="468630"/>
-          </a:xfrm>
-          <a:prstGeom prst="rect">
-            <a:avLst/>
-          </a:prstGeom>
-          <a:noFill/>
-        </p:spPr>
-        <p:txBody>
-          <a:bodyPr wrap="none" lIns="0" rIns="0" tIns="0" bIns="0">
-            <a:spAutoFit/>
-          </a:bodyPr>
-          <a:lstStyle/>
-          <a:p>
-            <a:pPr>
-              <a:lnSpc>
-                <a:spcPct val="135000"/>
-              </a:lnSpc>
-            </a:pPr>
-            <a:r>
-              <a:rPr sz="2200" b="0" i="0">
-                <a:solidFill>
-                  <a:srgbClr val="1B1B19"/>
-                </a:solidFill>
-                <a:latin typeface="IBM Plex Serif"/>
-              </a:rPr>
-              <a:t>Thank you.</a:t>
+              <a:t>Code: &lt;public repository URL&gt;.  Demo video: &lt;unlisted YouTube URL&gt;.  Thank you.</a:t>
             </a:r>
           </a:p>
         </p:txBody>
@@ -6917,7 +6307,7 @@
             <a:r>
               <a:rPr sz="1000" b="0" i="0">
                 <a:solidFill>
-                  <a:srgbClr val="75726B"/>
+                  <a:srgbClr val="6A675F"/>
                 </a:solidFill>
                 <a:latin typeface="IBM Plex Sans"/>
               </a:rPr>
@@ -7030,7 +6420,7 @@
             <a:r>
               <a:rPr sz="900" b="0" i="0">
                 <a:solidFill>
-                  <a:srgbClr val="75726B"/>
+                  <a:srgbClr val="6A675F"/>
                 </a:solidFill>
                 <a:latin typeface="IBM Plex Sans"/>
               </a:rPr>
@@ -7551,7 +6941,7 @@
             <a:r>
               <a:rPr sz="1000" b="0" i="0">
                 <a:solidFill>
-                  <a:srgbClr val="75726B"/>
+                  <a:srgbClr val="6A675F"/>
                 </a:solidFill>
                 <a:latin typeface="IBM Plex Sans"/>
               </a:rPr>
@@ -7664,7 +7054,7 @@
             <a:r>
               <a:rPr sz="900" b="0" i="0">
                 <a:solidFill>
-                  <a:srgbClr val="75726B"/>
+                  <a:srgbClr val="6A675F"/>
                 </a:solidFill>
                 <a:latin typeface="IBM Plex Sans"/>
               </a:rPr>
@@ -7703,7 +7093,7 @@
             <a:r>
               <a:rPr sz="1200" b="0" i="0">
                 <a:solidFill>
-                  <a:srgbClr val="75726B"/>
+                  <a:srgbClr val="6A675F"/>
                 </a:solidFill>
                 <a:latin typeface="IBM Plex Sans"/>
               </a:rPr>
@@ -7742,7 +7132,7 @@
             <a:r>
               <a:rPr sz="1200" b="0" i="0">
                 <a:solidFill>
-                  <a:srgbClr val="75726B"/>
+                  <a:srgbClr val="6A675F"/>
                 </a:solidFill>
                 <a:latin typeface="IBM Plex Sans"/>
               </a:rPr>
@@ -7781,7 +7171,7 @@
             <a:r>
               <a:rPr sz="1200" b="0" i="0">
                 <a:solidFill>
-                  <a:srgbClr val="75726B"/>
+                  <a:srgbClr val="6A675F"/>
                 </a:solidFill>
                 <a:latin typeface="IBM Plex Sans"/>
               </a:rPr>
@@ -7806,7 +7196,7 @@
           </a:prstGeom>
           <a:ln w="10160">
             <a:solidFill>
-              <a:srgbClr val="75726B"/>
+              <a:srgbClr val="6A675F"/>
             </a:solidFill>
           </a:ln>
         </p:spPr>
@@ -8864,7 +8254,7 @@
             <a:r>
               <a:rPr sz="1000" b="0" i="0">
                 <a:solidFill>
-                  <a:srgbClr val="75726B"/>
+                  <a:srgbClr val="6A675F"/>
                 </a:solidFill>
                 <a:latin typeface="IBM Plex Sans"/>
               </a:rPr>
@@ -8977,7 +8367,7 @@
             <a:r>
               <a:rPr sz="900" b="0" i="0">
                 <a:solidFill>
-                  <a:srgbClr val="75726B"/>
+                  <a:srgbClr val="6A675F"/>
                 </a:solidFill>
                 <a:latin typeface="IBM Plex Sans"/>
               </a:rPr>
@@ -9498,7 +8888,7 @@
             <a:r>
               <a:rPr sz="1000" b="0" i="0">
                 <a:solidFill>
-                  <a:srgbClr val="75726B"/>
+                  <a:srgbClr val="6A675F"/>
                 </a:solidFill>
                 <a:latin typeface="IBM Plex Sans"/>
               </a:rPr>
@@ -9611,7 +9001,7 @@
             <a:r>
               <a:rPr sz="900" b="0" i="0">
                 <a:solidFill>
-                  <a:srgbClr val="75726B"/>
+                  <a:srgbClr val="6A675F"/>
                 </a:solidFill>
                 <a:latin typeface="IBM Plex Sans"/>
               </a:rPr>
@@ -9700,7 +9090,7 @@
             <a:r>
               <a:rPr sz="1000" b="0" i="0">
                 <a:solidFill>
-                  <a:srgbClr val="75726B"/>
+                  <a:srgbClr val="6A675F"/>
                 </a:solidFill>
                 <a:latin typeface="IBM Plex Sans"/>
               </a:rPr>
@@ -9813,7 +9203,7 @@
             <a:r>
               <a:rPr sz="900" b="0" i="0">
                 <a:solidFill>
-                  <a:srgbClr val="75726B"/>
+                  <a:srgbClr val="6A675F"/>
                 </a:solidFill>
                 <a:latin typeface="IBM Plex Sans"/>
               </a:rPr>
@@ -10160,7 +9550,7 @@
             <a:r>
               <a:rPr sz="1100" b="0" i="0">
                 <a:solidFill>
-                  <a:srgbClr val="75726B"/>
+                  <a:srgbClr val="6A675F"/>
                 </a:solidFill>
                 <a:latin typeface="IBM Plex Sans"/>
               </a:rPr>
@@ -10225,7 +9615,7 @@
             <a:r>
               <a:rPr sz="1000" b="0" i="0">
                 <a:solidFill>
-                  <a:srgbClr val="75726B"/>
+                  <a:srgbClr val="6A675F"/>
                 </a:solidFill>
                 <a:latin typeface="IBM Plex Sans"/>
               </a:rPr>
@@ -10338,7 +9728,7 @@
             <a:r>
               <a:rPr sz="900" b="0" i="0">
                 <a:solidFill>
-                  <a:srgbClr val="75726B"/>
+                  <a:srgbClr val="6A675F"/>
                 </a:solidFill>
                 <a:latin typeface="IBM Plex Sans"/>
               </a:rPr>
@@ -10377,7 +9767,7 @@
             <a:r>
               <a:rPr sz="1100" b="0" i="0">
                 <a:solidFill>
-                  <a:srgbClr val="75726B"/>
+                  <a:srgbClr val="6A675F"/>
                 </a:solidFill>
                 <a:latin typeface="IBM Plex Sans"/>
               </a:rPr>
@@ -10416,7 +9806,7 @@
             <a:r>
               <a:rPr sz="1100" b="0" i="0">
                 <a:solidFill>
-                  <a:srgbClr val="75726B"/>
+                  <a:srgbClr val="6A675F"/>
                 </a:solidFill>
                 <a:latin typeface="IBM Plex Sans"/>
               </a:rPr>
@@ -10441,7 +9831,7 @@
           </a:prstGeom>
           <a:ln w="10160">
             <a:solidFill>
-              <a:srgbClr val="75726B"/>
+              <a:srgbClr val="6A675F"/>
             </a:solidFill>
           </a:ln>
         </p:spPr>
@@ -11226,7 +10616,7 @@
             <a:r>
               <a:rPr sz="1000" b="0" i="0">
                 <a:solidFill>
-                  <a:srgbClr val="75726B"/>
+                  <a:srgbClr val="6A675F"/>
                 </a:solidFill>
                 <a:latin typeface="IBM Plex Sans"/>
               </a:rPr>
@@ -11339,7 +10729,7 @@
             <a:r>
               <a:rPr sz="900" b="0" i="0">
                 <a:solidFill>
-                  <a:srgbClr val="75726B"/>
+                  <a:srgbClr val="6A675F"/>
                 </a:solidFill>
                 <a:latin typeface="IBM Plex Sans"/>
               </a:rPr>
@@ -11402,7 +10792,7 @@
             <a:r>
               <a:rPr sz="1150" b="0" i="0">
                 <a:solidFill>
-                  <a:srgbClr val="75726B"/>
+                  <a:srgbClr val="6A675F"/>
                 </a:solidFill>
                 <a:latin typeface="IBM Plex Sans"/>
               </a:rPr>
@@ -11441,7 +10831,7 @@
             <a:r>
               <a:rPr sz="1150" b="0" i="0">
                 <a:solidFill>
-                  <a:srgbClr val="75726B"/>
+                  <a:srgbClr val="6A675F"/>
                 </a:solidFill>
                 <a:latin typeface="IBM Plex Sans"/>
               </a:rPr>
@@ -11480,7 +10870,7 @@
             <a:r>
               <a:rPr sz="1150" b="0" i="0">
                 <a:solidFill>
-                  <a:srgbClr val="75726B"/>
+                  <a:srgbClr val="6A675F"/>
                 </a:solidFill>
                 <a:latin typeface="IBM Plex Sans"/>
               </a:rPr>
@@ -11519,7 +10909,7 @@
             <a:r>
               <a:rPr sz="1150" b="0" i="0">
                 <a:solidFill>
-                  <a:srgbClr val="75726B"/>
+                  <a:srgbClr val="6A675F"/>
                 </a:solidFill>
                 <a:latin typeface="IBM Plex Sans"/>
               </a:rPr>
@@ -11544,7 +10934,7 @@
           </a:prstGeom>
           <a:ln w="10160">
             <a:solidFill>
-              <a:srgbClr val="75726B"/>
+              <a:srgbClr val="6A675F"/>
             </a:solidFill>
           </a:ln>
         </p:spPr>
@@ -12428,7 +11818,7 @@
             <a:r>
               <a:rPr sz="1200" b="0" i="0">
                 <a:solidFill>
-                  <a:srgbClr val="75726B"/>
+                  <a:srgbClr val="6A675F"/>
                 </a:solidFill>
                 <a:latin typeface="IBM Plex Sans"/>
               </a:rPr>
@@ -12493,7 +11883,7 @@
             <a:r>
               <a:rPr sz="1000" b="0" i="0">
                 <a:solidFill>
-                  <a:srgbClr val="75726B"/>
+                  <a:srgbClr val="6A675F"/>
                 </a:solidFill>
                 <a:latin typeface="IBM Plex Sans"/>
               </a:rPr>
@@ -12606,7 +11996,7 @@
             <a:r>
               <a:rPr sz="900" b="0" i="0">
                 <a:solidFill>
-                  <a:srgbClr val="75726B"/>
+                  <a:srgbClr val="6A675F"/>
                 </a:solidFill>
                 <a:latin typeface="IBM Plex Sans"/>
               </a:rPr>

</xml_diff>

<commit_message>
Simpler, larger interface (version 1.2)
* Larger type throughout and bigger charts.
* Ward opens on patients who need attention, with five plain columns.
* Patient overview leads with one sentence, the chart and alerts; detail
  (reasons, meal entry, history, two week pattern) opens on demand.
* Health record moved to its own tab; breadcrumb navigation.
* What if leads with the best changes for the patient as cards.
* Masthead trimmed to clock, play, Replay and Settings menus.
* Plain language problem names and heart health reasons.
* Screenshots, slides, README and video script updated; a11y audit clean.
</commit_message>
<xml_diff>
--- a/docs/presentation.pptx
+++ b/docs/presentation.pptx
@@ -4626,7 +4626,7 @@
         <p:spPr>
           <a:xfrm>
             <a:off x="6263640" y="1325880"/>
-            <a:ext cx="5191690" cy="3694176"/>
+            <a:ext cx="4324607" cy="3694176"/>
           </a:xfrm>
           <a:prstGeom prst="rect">
             <a:avLst/>
@@ -9508,7 +9508,7 @@
         <p:spPr>
           <a:xfrm>
             <a:off x="6583680" y="1554480"/>
-            <a:ext cx="4195280" cy="4480560"/>
+            <a:ext cx="4937760" cy="4066519"/>
           </a:xfrm>
           <a:prstGeom prst="rect">
             <a:avLst/>

</xml_diff>

<commit_message>
Version 1.3: easier navigation between and within patients
Patient list beside each patient with Previous and Next, one alert banner
with its actions, three task tabs (Today, Try a change, Record), heart risk
folded into Today, clinical note as a printable sheet, a separate demo replay
strip, patient search in the top bar, and one vocabulary throughout.
</commit_message>
<xml_diff>
--- a/docs/presentation.pptx
+++ b/docs/presentation.pptx
@@ -4626,7 +4626,7 @@
         <p:spPr>
           <a:xfrm>
             <a:off x="6263640" y="1325880"/>
-            <a:ext cx="4324607" cy="3694176"/>
+            <a:ext cx="5394960" cy="3558275"/>
           </a:xfrm>
           <a:prstGeom prst="rect">
             <a:avLst/>
@@ -9508,7 +9508,7 @@
         <p:spPr>
           <a:xfrm>
             <a:off x="6583680" y="1554480"/>
-            <a:ext cx="4937760" cy="4066519"/>
+            <a:ext cx="3721395" cy="4480560"/>
           </a:xfrm>
           <a:prstGeom prst="rect">
             <a:avLst/>

</xml_diff>

<commit_message>
Version 1.5: what ifs checked against the reference simulator, and the loop with the patient
The data generator's physiology can now restart from saved state, so any
patient can be rebuilt exactly and re-run with one change applied to what they
really ate. The twin's what ifs are checked against it per change (Try a
change) and across 316 moments in 40 test patients (reports/counterfactual.md):
direction right 76% of the time, weak spot an earlier meal.

Also: what would sharpen the forecast (meal spread re-run through the twin,
fingerstick and sync gaps); an animated view inside the twin; questions in
plain words (offline phrase matcher, optional model behind an API key); the
patient's phone in Hindi, Tamil or English with nudges, replies, a planned walk
that enters the forecast and a replay that follows the reference, and the
result to both sides; festival planner; ward level what if; twin health with
refit; Listen buttons. Fixes a missing card when glucose is already above 180.
</commit_message>
<xml_diff>
--- a/docs/presentation.pptx
+++ b/docs/presentation.pptx
@@ -4196,74 +4196,74 @@
         <p:spPr>
           <a:xfrm>
             <a:off x="7863840" y="1463040"/>
-            <a:ext cx="3840480" cy="3211830"/>
-          </a:xfrm>
-          <a:prstGeom prst="rect">
-            <a:avLst/>
-          </a:prstGeom>
-          <a:noFill/>
-        </p:spPr>
-        <p:txBody>
-          <a:bodyPr wrap="none" lIns="0" rIns="0" tIns="0" bIns="0">
-            <a:spAutoFit/>
-          </a:bodyPr>
-          <a:lstStyle/>
-          <a:p>
-            <a:pPr>
-              <a:lnSpc>
-                <a:spcPct val="135000"/>
-              </a:lnSpc>
-            </a:pPr>
-            <a:r>
-              <a:rPr sz="1300" b="0" i="0">
-                <a:solidFill>
-                  <a:srgbClr val="1B1B19"/>
-                </a:solidFill>
-                <a:latin typeface="IBM Plex Sans"/>
-              </a:rPr>
-              <a:t>•  19:45. The hybrid forecast expects dinner at</a:t>
-            </a:r>
-          </a:p>
-          <a:p>
-            <a:pPr>
-              <a:lnSpc>
-                <a:spcPct val="135000"/>
-              </a:lnSpc>
-            </a:pPr>
-            <a:r>
-              <a:rPr sz="1300" b="0" i="0">
-                <a:solidFill>
-                  <a:srgbClr val="1B1B19"/>
-                </a:solidFill>
-                <a:latin typeface="IBM Plex Sans"/>
-              </a:rPr>
-              <a:t>   20:15 and a peak near 278 mg/dL, after three</a:t>
-            </a:r>
-          </a:p>
-          <a:p>
-            <a:pPr>
-              <a:lnSpc>
-                <a:spcPct val="135000"/>
-              </a:lnSpc>
-            </a:pPr>
-            <a:r>
-              <a:rPr sz="1300" b="0" i="0">
-                <a:solidFill>
-                  <a:srgbClr val="1B1B19"/>
-                </a:solidFill>
-                <a:latin typeface="IBM Plex Sans"/>
-              </a:rPr>
-              <a:t>   nights of 4.9 h sleep.</a:t>
-            </a:r>
-          </a:p>
-          <a:p>
-            <a:pPr>
-              <a:lnSpc>
-                <a:spcPct val="135000"/>
-              </a:lnSpc>
-            </a:pPr>
-            <a:r>
-              <a:rPr sz="1300" b="0" i="0">
+            <a:ext cx="3840480" cy="4000500"/>
+          </a:xfrm>
+          <a:prstGeom prst="rect">
+            <a:avLst/>
+          </a:prstGeom>
+          <a:noFill/>
+        </p:spPr>
+        <p:txBody>
+          <a:bodyPr wrap="none" lIns="0" rIns="0" tIns="0" bIns="0">
+            <a:spAutoFit/>
+          </a:bodyPr>
+          <a:lstStyle/>
+          <a:p>
+            <a:pPr>
+              <a:lnSpc>
+                <a:spcPct val="135000"/>
+              </a:lnSpc>
+            </a:pPr>
+            <a:r>
+              <a:rPr sz="1200" b="0" i="0">
+                <a:solidFill>
+                  <a:srgbClr val="1B1B19"/>
+                </a:solidFill>
+                <a:latin typeface="IBM Plex Sans"/>
+              </a:rPr>
+              <a:t>•  19:45. The hybrid forecast expects dinner at 20:15</a:t>
+            </a:r>
+          </a:p>
+          <a:p>
+            <a:pPr>
+              <a:lnSpc>
+                <a:spcPct val="135000"/>
+              </a:lnSpc>
+            </a:pPr>
+            <a:r>
+              <a:rPr sz="1200" b="0" i="0">
+                <a:solidFill>
+                  <a:srgbClr val="1B1B19"/>
+                </a:solidFill>
+                <a:latin typeface="IBM Plex Sans"/>
+              </a:rPr>
+              <a:t>   and a peak near 278 mg/dL, after three nights of</a:t>
+            </a:r>
+          </a:p>
+          <a:p>
+            <a:pPr>
+              <a:lnSpc>
+                <a:spcPct val="135000"/>
+              </a:lnSpc>
+            </a:pPr>
+            <a:r>
+              <a:rPr sz="1200" b="0" i="0">
+                <a:solidFill>
+                  <a:srgbClr val="1B1B19"/>
+                </a:solidFill>
+                <a:latin typeface="IBM Plex Sans"/>
+              </a:rPr>
+              <a:t>   4.9 h sleep.</a:t>
+            </a:r>
+          </a:p>
+          <a:p>
+            <a:pPr>
+              <a:lnSpc>
+                <a:spcPct val="135000"/>
+              </a:lnSpc>
+            </a:pPr>
+            <a:r>
+              <a:rPr sz="1200" b="0" i="0">
                 <a:solidFill>
                   <a:srgbClr val="1B1B19"/>
                 </a:solidFill>
@@ -4279,55 +4279,55 @@
               </a:lnSpc>
             </a:pPr>
             <a:r>
-              <a:rPr sz="1300" b="0" i="0">
-                <a:solidFill>
-                  <a:srgbClr val="1B1B19"/>
-                </a:solidFill>
-                <a:latin typeface="IBM Plex Sans"/>
-              </a:rPr>
-              <a:t>•  A 15 minute walk after dinner takes 15 mg/dL</a:t>
-            </a:r>
-          </a:p>
-          <a:p>
-            <a:pPr>
-              <a:lnSpc>
-                <a:spcPct val="135000"/>
-              </a:lnSpc>
-            </a:pPr>
-            <a:r>
-              <a:rPr sz="1300" b="0" i="0">
-                <a:solidFill>
-                  <a:srgbClr val="1B1B19"/>
-                </a:solidFill>
-                <a:latin typeface="IBM Plex Sans"/>
-              </a:rPr>
-              <a:t>   off the twin's 6 hour peak. Millets instead of</a:t>
-            </a:r>
-          </a:p>
-          <a:p>
-            <a:pPr>
-              <a:lnSpc>
-                <a:spcPct val="135000"/>
-              </a:lnSpc>
-            </a:pPr>
-            <a:r>
-              <a:rPr sz="1300" b="0" i="0">
-                <a:solidFill>
-                  <a:srgbClr val="1B1B19"/>
-                </a:solidFill>
-                <a:latin typeface="IBM Plex Sans"/>
-              </a:rPr>
-              <a:t>   white rice take 48.</a:t>
-            </a:r>
-          </a:p>
-          <a:p>
-            <a:pPr>
-              <a:lnSpc>
-                <a:spcPct val="135000"/>
-              </a:lnSpc>
-            </a:pPr>
-            <a:r>
-              <a:rPr sz="1300" b="0" i="0">
+              <a:rPr sz="1200" b="0" i="0">
+                <a:solidFill>
+                  <a:srgbClr val="1B1B19"/>
+                </a:solidFill>
+                <a:latin typeface="IBM Plex Sans"/>
+              </a:rPr>
+              <a:t>•  A 15 minute walk after dinner takes 15 mg/dL off</a:t>
+            </a:r>
+          </a:p>
+          <a:p>
+            <a:pPr>
+              <a:lnSpc>
+                <a:spcPct val="135000"/>
+              </a:lnSpc>
+            </a:pPr>
+            <a:r>
+              <a:rPr sz="1200" b="0" i="0">
+                <a:solidFill>
+                  <a:srgbClr val="1B1B19"/>
+                </a:solidFill>
+                <a:latin typeface="IBM Plex Sans"/>
+              </a:rPr>
+              <a:t>   the twin's 6 hour peak. Millets instead of white</a:t>
+            </a:r>
+          </a:p>
+          <a:p>
+            <a:pPr>
+              <a:lnSpc>
+                <a:spcPct val="135000"/>
+              </a:lnSpc>
+            </a:pPr>
+            <a:r>
+              <a:rPr sz="1200" b="0" i="0">
+                <a:solidFill>
+                  <a:srgbClr val="1B1B19"/>
+                </a:solidFill>
+                <a:latin typeface="IBM Plex Sans"/>
+              </a:rPr>
+              <a:t>   rice take 48.</a:t>
+            </a:r>
+          </a:p>
+          <a:p>
+            <a:pPr>
+              <a:lnSpc>
+                <a:spcPct val="135000"/>
+              </a:lnSpc>
+            </a:pPr>
+            <a:r>
+              <a:rPr sz="1200" b="0" i="0">
                 <a:solidFill>
                   <a:srgbClr val="1B1B19"/>
                 </a:solidFill>
@@ -4343,39 +4343,39 @@
               </a:lnSpc>
             </a:pPr>
             <a:r>
-              <a:rPr sz="1300" b="0" i="0">
-                <a:solidFill>
-                  <a:srgbClr val="1B1B19"/>
-                </a:solidFill>
-                <a:latin typeface="IBM Plex Sans"/>
-              </a:rPr>
-              <a:t>•  Together: peak 57 mg/dL lower and 40 minutes</a:t>
-            </a:r>
-          </a:p>
-          <a:p>
-            <a:pPr>
-              <a:lnSpc>
-                <a:spcPct val="135000"/>
-              </a:lnSpc>
-            </a:pPr>
-            <a:r>
-              <a:rPr sz="1300" b="0" i="0">
-                <a:solidFill>
-                  <a:srgbClr val="1B1B19"/>
-                </a:solidFill>
-                <a:latin typeface="IBM Plex Sans"/>
-              </a:rPr>
-              <a:t>   less above 180.</a:t>
-            </a:r>
-          </a:p>
-          <a:p>
-            <a:pPr>
-              <a:lnSpc>
-                <a:spcPct val="135000"/>
-              </a:lnSpc>
-            </a:pPr>
-            <a:r>
-              <a:rPr sz="1300" b="0" i="0">
+              <a:rPr sz="1200" b="0" i="0">
+                <a:solidFill>
+                  <a:srgbClr val="1B1B19"/>
+                </a:solidFill>
+                <a:latin typeface="IBM Plex Sans"/>
+              </a:rPr>
+              <a:t>•  Together: peak 57 mg/dL lower and 40 minutes less</a:t>
+            </a:r>
+          </a:p>
+          <a:p>
+            <a:pPr>
+              <a:lnSpc>
+                <a:spcPct val="135000"/>
+              </a:lnSpc>
+            </a:pPr>
+            <a:r>
+              <a:rPr sz="1200" b="0" i="0">
+                <a:solidFill>
+                  <a:srgbClr val="1B1B19"/>
+                </a:solidFill>
+                <a:latin typeface="IBM Plex Sans"/>
+              </a:rPr>
+              <a:t>   above 180.</a:t>
+            </a:r>
+          </a:p>
+          <a:p>
+            <a:pPr>
+              <a:lnSpc>
+                <a:spcPct val="135000"/>
+              </a:lnSpc>
+            </a:pPr>
+            <a:r>
+              <a:rPr sz="1200" b="0" i="0">
                 <a:solidFill>
                   <a:srgbClr val="1B1B19"/>
                 </a:solidFill>
@@ -4391,7 +4391,7 @@
               </a:lnSpc>
             </a:pPr>
             <a:r>
-              <a:rPr sz="1300" b="0" i="0">
+              <a:rPr sz="1200" b="0" i="0">
                 <a:solidFill>
                   <a:srgbClr val="1B1B19"/>
                 </a:solidFill>
@@ -4407,29 +4407,109 @@
               </a:lnSpc>
             </a:pPr>
             <a:r>
-              <a:rPr sz="1300" b="0" i="0">
-                <a:solidFill>
-                  <a:srgbClr val="1B1B19"/>
-                </a:solidFill>
-                <a:latin typeface="IBM Plex Sans"/>
-              </a:rPr>
-              <a:t>   tonight (it can only move to 19:50). The twin</a:t>
-            </a:r>
-          </a:p>
-          <a:p>
-            <a:pPr>
-              <a:lnSpc>
-                <a:spcPct val="135000"/>
-              </a:lnSpc>
-            </a:pPr>
-            <a:r>
-              <a:rPr sz="1300" b="0" i="0">
-                <a:solidFill>
-                  <a:srgbClr val="1B1B19"/>
-                </a:solidFill>
-                <a:latin typeface="IBM Plex Sans"/>
-              </a:rPr>
-              <a:t>   can say no.</a:t>
+              <a:rPr sz="1200" b="0" i="0">
+                <a:solidFill>
+                  <a:srgbClr val="1B1B19"/>
+                </a:solidFill>
+                <a:latin typeface="IBM Plex Sans"/>
+              </a:rPr>
+              <a:t>   tonight (it can only move to 19:50). The twin can</a:t>
+            </a:r>
+          </a:p>
+          <a:p>
+            <a:pPr>
+              <a:lnSpc>
+                <a:spcPct val="135000"/>
+              </a:lnSpc>
+            </a:pPr>
+            <a:r>
+              <a:rPr sz="1200" b="0" i="0">
+                <a:solidFill>
+                  <a:srgbClr val="1B1B19"/>
+                </a:solidFill>
+                <a:latin typeface="IBM Plex Sans"/>
+              </a:rPr>
+              <a:t>   say no.</a:t>
+            </a:r>
+          </a:p>
+          <a:p>
+            <a:pPr>
+              <a:lnSpc>
+                <a:spcPct val="135000"/>
+              </a:lnSpc>
+            </a:pPr>
+            <a:r>
+              <a:rPr sz="1200" b="0" i="0">
+                <a:solidFill>
+                  <a:srgbClr val="1B1B19"/>
+                </a:solidFill>
+                <a:latin typeface="IBM Plex Sans"/>
+              </a:rPr>
+              <a:t/>
+            </a:r>
+          </a:p>
+          <a:p>
+            <a:pPr>
+              <a:lnSpc>
+                <a:spcPct val="135000"/>
+              </a:lnSpc>
+            </a:pPr>
+            <a:r>
+              <a:rPr sz="1200" b="0" i="0">
+                <a:solidFill>
+                  <a:srgbClr val="1B1B19"/>
+                </a:solidFill>
+                <a:latin typeface="IBM Plex Sans"/>
+              </a:rPr>
+              <a:t>•  Checked against the reference simulator the twin</a:t>
+            </a:r>
+          </a:p>
+          <a:p>
+            <a:pPr>
+              <a:lnSpc>
+                <a:spcPct val="135000"/>
+              </a:lnSpc>
+            </a:pPr>
+            <a:r>
+              <a:rPr sz="1200" b="0" i="0">
+                <a:solidFill>
+                  <a:srgbClr val="1B1B19"/>
+                </a:solidFill>
+                <a:latin typeface="IBM Plex Sans"/>
+              </a:rPr>
+              <a:t>   never sees: across 316 moments in 40 test patients</a:t>
+            </a:r>
+          </a:p>
+          <a:p>
+            <a:pPr>
+              <a:lnSpc>
+                <a:spcPct val="135000"/>
+              </a:lnSpc>
+            </a:pPr>
+            <a:r>
+              <a:rPr sz="1200" b="0" i="0">
+                <a:solidFill>
+                  <a:srgbClr val="1B1B19"/>
+                </a:solidFill>
+                <a:latin typeface="IBM Plex Sans"/>
+              </a:rPr>
+              <a:t>   the twin gets the direction of a change right 76%</a:t>
+            </a:r>
+          </a:p>
+          <a:p>
+            <a:pPr>
+              <a:lnSpc>
+                <a:spcPct val="135000"/>
+              </a:lnSpc>
+            </a:pPr>
+            <a:r>
+              <a:rPr sz="1200" b="0" i="0">
+                <a:solidFill>
+                  <a:srgbClr val="1B1B19"/>
+                </a:solidFill>
+                <a:latin typeface="IBM Plex Sans"/>
+              </a:rPr>
+              <a:t>   of the time.</a:t>
             </a:r>
           </a:p>
         </p:txBody>
@@ -4643,7 +4723,7 @@
       </p:pic>
       <p:pic>
         <p:nvPicPr>
-          <p:cNvPr id="7" name="Picture 6" descr="15_earlier_alerts.png"/>
+          <p:cNvPr id="7" name="Picture 6" descr="25_phone_loop.png"/>
           <p:cNvPicPr>
             <a:picLocks noChangeAspect="1"/>
           </p:cNvPicPr>
@@ -4791,7 +4871,7 @@
                 </a:solidFill>
                 <a:latin typeface="IBM Plex Sans"/>
               </a:rPr>
-              <a:t>3. Every alert's outcome and what the team did; a week plan checked against</a:t>
+              <a:t>3. A suggestion to the patient's phone in Hindi, Tamil or English; the reply</a:t>
             </a:r>
           </a:p>
           <a:p>
@@ -4807,7 +4887,7 @@
                 </a:solidFill>
                 <a:latin typeface="IBM Plex Sans"/>
               </a:rPr>
-              <a:t>what happened. 4. Shift handover, daily digest, SOAP note, patient view in</a:t>
+              <a:t>enters the forecast and the outcome comes back to both sides. 4. Every alert's</a:t>
             </a:r>
           </a:p>
           <a:p>
@@ -4823,7 +4903,7 @@
                 </a:solidFill>
                 <a:latin typeface="IBM Plex Sans"/>
               </a:rPr>
-              <a:t>English, Hindi or Tamil.</a:t>
+              <a:t>outcome, week plans checked a week later, handover, festival planner.</a:t>
             </a:r>
           </a:p>
         </p:txBody>
@@ -9652,7 +9732,7 @@
         <p:spPr>
           <a:xfrm>
             <a:off x="6583680" y="1554480"/>
-            <a:ext cx="3518764" cy="4480560"/>
+            <a:ext cx="3082954" cy="4480560"/>
           </a:xfrm>
           <a:prstGeom prst="rect">
             <a:avLst/>

</xml_diff>

<commit_message>
Team details, demo video section, title slide
</commit_message>
<xml_diff>
--- a/docs/presentation.pptx
+++ b/docs/presentation.pptx
@@ -3335,7 +3335,7 @@
                 </a:solidFill>
                 <a:latin typeface="IBM Plex Sans"/>
               </a:rPr>
-              <a:t>&lt;TeamName&gt;, &lt;CollegeName&gt; / &lt;Incubator&gt;</a:t>
+              <a:t>Team pushkalayeddula, Anurag University</a:t>
             </a:r>
           </a:p>
         </p:txBody>
@@ -3374,7 +3374,7 @@
                 </a:solidFill>
                 <a:latin typeface="IBM Plex Sans"/>
               </a:rPr>
-              <a:t>&lt;Member 1, role&gt;   &lt;Member 2, role&gt;   &lt;Member 3, role&gt;   &lt;Member 4, role&gt;   &lt;team email&gt;</a:t>
+              <a:t>Built by Pushkala Yeddula: data, twin, models, dashboard, tests and documents</a:t>
             </a:r>
           </a:p>
         </p:txBody>

</xml_diff>